<commit_message>
feat: add new evaluation tasks and update assets for LibreOffice, Inkscape, Kdenlive, Blender domains
- Add 30+ new task JSONs for libreoffice_impr_njc, libreoffice_calc_njc, libreoffice_writ_njc, kdenlive, blender, inkscape
- Add backup_json directory and example_final task configs
- Update LibreOffice Calc/Impress/Writer asset files (.xlsx, .pptx, .docx)
- Add libreoffice_suite_njc task examples and windows evaluator config
- Update taiji_task scripts (r3agentv3, interactive, vllm)
- Add test scripts: test_thinking_mode.py, test_user_model.py, check_task_coverage.py
- Remove deprecated evaluation list JSONs (gimp_new, inkscape_all, kdenlive_all, etc.)
- Update example_final_interactive_all and example_final_non_interactive_all task lists

Co-Authored-By: Claude Sonnet 4.6 (1M context) <noreply@anthropic.com>
</commit_message>
<xml_diff>
--- a/assets/libreoffice_impr_njc/06706431-3011-417a-bd22-36869b25d1fe/Game Theory.pptx
+++ b/assets/libreoffice_impr_njc/06706431-3011-417a-bd22-36869b25d1fe/Game Theory.pptx
@@ -308,7 +308,7 @@
             <a:pPr algn="r">
               <a:buNone/>
             </a:pPr>
-            <a:fld id="{321D51BB-52EC-4CCB-BB00-8C7625A76500}" type="slidenum">
+            <a:fld id="{0C36BBD8-9DF3-4EF4-915B-CE906B20755A}" type="slidenum">
               <a:rPr b="0" lang="en-HK" sz="1400" spc="-1" strike="noStrike">
                 <a:latin typeface="Times New Roman"/>
               </a:rPr>
@@ -356,7 +356,7 @@
         <p:spPr>
           <a:xfrm>
             <a:off x="685800" y="1143000"/>
-            <a:ext cx="5485680" cy="3085560"/>
+            <a:ext cx="5485320" cy="3085200"/>
           </a:xfrm>
           <a:prstGeom prst="rect">
             <a:avLst/>
@@ -379,7 +379,7 @@
         <p:spPr>
           <a:xfrm>
             <a:off x="685800" y="4400640"/>
-            <a:ext cx="5485680" cy="3599640"/>
+            <a:ext cx="5485320" cy="3599280"/>
           </a:xfrm>
           <a:prstGeom prst="rect">
             <a:avLst/>
@@ -413,7 +413,7 @@
         <p:spPr>
           <a:xfrm>
             <a:off x="3884760" y="8685360"/>
-            <a:ext cx="2971080" cy="457920"/>
+            <a:ext cx="2970720" cy="457560"/>
           </a:xfrm>
           <a:prstGeom prst="rect">
             <a:avLst/>
@@ -445,7 +445,7 @@
               </a:lnSpc>
               <a:buNone/>
             </a:pPr>
-            <a:fld id="{7DD5CC6A-8668-415B-9371-34139ADE8597}" type="slidenum">
+            <a:fld id="{85FA9654-DF36-4ADD-8D45-E7DCC61AC2B3}" type="slidenum">
               <a:rPr b="0" lang="en-US" sz="1200" spc="-1" strike="noStrike">
                 <a:latin typeface="Times New Roman"/>
               </a:rPr>
@@ -492,7 +492,7 @@
         <p:spPr>
           <a:xfrm>
             <a:off x="685800" y="1143000"/>
-            <a:ext cx="5485680" cy="3085560"/>
+            <a:ext cx="5485320" cy="3085200"/>
           </a:xfrm>
           <a:prstGeom prst="rect">
             <a:avLst/>
@@ -515,7 +515,7 @@
         <p:spPr>
           <a:xfrm>
             <a:off x="685800" y="4400640"/>
-            <a:ext cx="5485680" cy="3599640"/>
+            <a:ext cx="5485320" cy="3599280"/>
           </a:xfrm>
           <a:prstGeom prst="rect">
             <a:avLst/>
@@ -549,7 +549,7 @@
         <p:spPr>
           <a:xfrm>
             <a:off x="3884760" y="8685360"/>
-            <a:ext cx="2971080" cy="457920"/>
+            <a:ext cx="2970720" cy="457560"/>
           </a:xfrm>
           <a:prstGeom prst="rect">
             <a:avLst/>
@@ -581,7 +581,7 @@
               </a:lnSpc>
               <a:buNone/>
             </a:pPr>
-            <a:fld id="{158FB622-FECA-4987-B7F7-EA4EBA90E682}" type="slidenum">
+            <a:fld id="{85CA4FC3-3878-4A12-BD9F-7B766B7ACF04}" type="slidenum">
               <a:rPr b="0" lang="en-US" sz="1200" spc="-1" strike="noStrike">
                 <a:latin typeface="Times New Roman"/>
               </a:rPr>
@@ -628,7 +628,7 @@
         <p:spPr>
           <a:xfrm>
             <a:off x="685800" y="1143000"/>
-            <a:ext cx="5485680" cy="3085560"/>
+            <a:ext cx="5485320" cy="3085200"/>
           </a:xfrm>
           <a:prstGeom prst="rect">
             <a:avLst/>
@@ -651,7 +651,7 @@
         <p:spPr>
           <a:xfrm>
             <a:off x="685800" y="4400640"/>
-            <a:ext cx="5485680" cy="3599640"/>
+            <a:ext cx="5485320" cy="3599280"/>
           </a:xfrm>
           <a:prstGeom prst="rect">
             <a:avLst/>
@@ -685,7 +685,7 @@
         <p:spPr>
           <a:xfrm>
             <a:off x="3884760" y="8685360"/>
-            <a:ext cx="2971080" cy="457920"/>
+            <a:ext cx="2970720" cy="457560"/>
           </a:xfrm>
           <a:prstGeom prst="rect">
             <a:avLst/>
@@ -717,7 +717,7 @@
               </a:lnSpc>
               <a:buNone/>
             </a:pPr>
-            <a:fld id="{E638ED3C-92EF-497B-B1BF-B840DA3767B0}" type="slidenum">
+            <a:fld id="{A6438B91-1C7B-4C71-9474-B7CEDDD23F07}" type="slidenum">
               <a:rPr b="0" lang="en-US" sz="1200" spc="-1" strike="noStrike">
                 <a:latin typeface="Times New Roman"/>
               </a:rPr>
@@ -764,7 +764,7 @@
         <p:spPr>
           <a:xfrm>
             <a:off x="685800" y="1143000"/>
-            <a:ext cx="5485680" cy="3085560"/>
+            <a:ext cx="5485320" cy="3085200"/>
           </a:xfrm>
           <a:prstGeom prst="rect">
             <a:avLst/>
@@ -787,7 +787,7 @@
         <p:spPr>
           <a:xfrm>
             <a:off x="685800" y="4400640"/>
-            <a:ext cx="5485680" cy="3599640"/>
+            <a:ext cx="5485320" cy="3599280"/>
           </a:xfrm>
           <a:prstGeom prst="rect">
             <a:avLst/>
@@ -821,7 +821,7 @@
         <p:spPr>
           <a:xfrm>
             <a:off x="3884760" y="8685360"/>
-            <a:ext cx="2971080" cy="457920"/>
+            <a:ext cx="2970720" cy="457560"/>
           </a:xfrm>
           <a:prstGeom prst="rect">
             <a:avLst/>
@@ -853,7 +853,7 @@
               </a:lnSpc>
               <a:buNone/>
             </a:pPr>
-            <a:fld id="{60DD8C84-A333-4D37-85EB-54744A752DB9}" type="slidenum">
+            <a:fld id="{60D92983-C8AD-4814-B15E-1ECB6E5DD6EE}" type="slidenum">
               <a:rPr b="0" lang="en-US" sz="1200" spc="-1" strike="noStrike">
                 <a:latin typeface="Times New Roman"/>
               </a:rPr>
@@ -900,7 +900,7 @@
         <p:spPr>
           <a:xfrm>
             <a:off x="685800" y="1143000"/>
-            <a:ext cx="5485680" cy="3085560"/>
+            <a:ext cx="5485320" cy="3085200"/>
           </a:xfrm>
           <a:prstGeom prst="rect">
             <a:avLst/>
@@ -923,7 +923,7 @@
         <p:spPr>
           <a:xfrm>
             <a:off x="685800" y="4400640"/>
-            <a:ext cx="5485680" cy="3599640"/>
+            <a:ext cx="5485320" cy="3599280"/>
           </a:xfrm>
           <a:prstGeom prst="rect">
             <a:avLst/>
@@ -957,7 +957,7 @@
         <p:spPr>
           <a:xfrm>
             <a:off x="3884760" y="8685360"/>
-            <a:ext cx="2971080" cy="457920"/>
+            <a:ext cx="2970720" cy="457560"/>
           </a:xfrm>
           <a:prstGeom prst="rect">
             <a:avLst/>
@@ -989,7 +989,7 @@
               </a:lnSpc>
               <a:buNone/>
             </a:pPr>
-            <a:fld id="{C8D1C1C0-21B4-44A7-8101-41890270D9AE}" type="slidenum">
+            <a:fld id="{29C1281F-0C23-4080-88C8-0F77FEC06FB7}" type="slidenum">
               <a:rPr b="0" lang="en-US" sz="1200" spc="-1" strike="noStrike">
                 <a:latin typeface="Times New Roman"/>
               </a:rPr>
@@ -1036,7 +1036,7 @@
         <p:spPr>
           <a:xfrm>
             <a:off x="685800" y="1143000"/>
-            <a:ext cx="5485680" cy="3085560"/>
+            <a:ext cx="5485320" cy="3085200"/>
           </a:xfrm>
           <a:prstGeom prst="rect">
             <a:avLst/>
@@ -1059,7 +1059,7 @@
         <p:spPr>
           <a:xfrm>
             <a:off x="685800" y="4400640"/>
-            <a:ext cx="5485680" cy="3599640"/>
+            <a:ext cx="5485320" cy="3599280"/>
           </a:xfrm>
           <a:prstGeom prst="rect">
             <a:avLst/>
@@ -1093,7 +1093,7 @@
         <p:spPr>
           <a:xfrm>
             <a:off x="3884760" y="8685360"/>
-            <a:ext cx="2971080" cy="457920"/>
+            <a:ext cx="2970720" cy="457560"/>
           </a:xfrm>
           <a:prstGeom prst="rect">
             <a:avLst/>
@@ -1125,7 +1125,7 @@
               </a:lnSpc>
               <a:buNone/>
             </a:pPr>
-            <a:fld id="{8D5C699F-67CE-4420-B718-297EF72B3F69}" type="slidenum">
+            <a:fld id="{BC6AD56A-8110-4A3C-8087-6E6B6EC4336D}" type="slidenum">
               <a:rPr b="0" lang="en-US" sz="1200" spc="-1" strike="noStrike">
                 <a:latin typeface="Times New Roman"/>
               </a:rPr>
@@ -1172,7 +1172,7 @@
         <p:spPr>
           <a:xfrm>
             <a:off x="685800" y="1143000"/>
-            <a:ext cx="5485680" cy="3085560"/>
+            <a:ext cx="5485320" cy="3085200"/>
           </a:xfrm>
           <a:prstGeom prst="rect">
             <a:avLst/>
@@ -1195,7 +1195,7 @@
         <p:spPr>
           <a:xfrm>
             <a:off x="685800" y="4400640"/>
-            <a:ext cx="5485680" cy="3599640"/>
+            <a:ext cx="5485320" cy="3599280"/>
           </a:xfrm>
           <a:prstGeom prst="rect">
             <a:avLst/>
@@ -1229,7 +1229,7 @@
         <p:spPr>
           <a:xfrm>
             <a:off x="3884760" y="8685360"/>
-            <a:ext cx="2971080" cy="457920"/>
+            <a:ext cx="2970720" cy="457560"/>
           </a:xfrm>
           <a:prstGeom prst="rect">
             <a:avLst/>
@@ -1261,7 +1261,7 @@
               </a:lnSpc>
               <a:buNone/>
             </a:pPr>
-            <a:fld id="{FE6B0EEC-1CEC-4AB1-B33F-2688186E8E19}" type="slidenum">
+            <a:fld id="{EEE94CDA-802C-462B-8A44-0FEE43418D6F}" type="slidenum">
               <a:rPr b="0" lang="en-US" sz="1200" spc="-1" strike="noStrike">
                 <a:latin typeface="Times New Roman"/>
               </a:rPr>
@@ -1308,7 +1308,7 @@
         <p:spPr>
           <a:xfrm>
             <a:off x="685800" y="1143000"/>
-            <a:ext cx="5485680" cy="3085560"/>
+            <a:ext cx="5485320" cy="3085200"/>
           </a:xfrm>
           <a:prstGeom prst="rect">
             <a:avLst/>
@@ -1331,7 +1331,7 @@
         <p:spPr>
           <a:xfrm>
             <a:off x="685800" y="4400640"/>
-            <a:ext cx="5485680" cy="3599640"/>
+            <a:ext cx="5485320" cy="3599280"/>
           </a:xfrm>
           <a:prstGeom prst="rect">
             <a:avLst/>
@@ -1365,7 +1365,7 @@
         <p:spPr>
           <a:xfrm>
             <a:off x="3884760" y="8685360"/>
-            <a:ext cx="2971080" cy="457920"/>
+            <a:ext cx="2970720" cy="457560"/>
           </a:xfrm>
           <a:prstGeom prst="rect">
             <a:avLst/>
@@ -1397,7 +1397,7 @@
               </a:lnSpc>
               <a:buNone/>
             </a:pPr>
-            <a:fld id="{C7539347-F76C-4453-81BC-A9723C27FE44}" type="slidenum">
+            <a:fld id="{74F55A3E-E1D2-4F2E-8A1A-4F230F85DF47}" type="slidenum">
               <a:rPr b="0" lang="en-US" sz="1200" spc="-1" strike="noStrike">
                 <a:latin typeface="Times New Roman"/>
               </a:rPr>
@@ -1444,7 +1444,7 @@
         <p:spPr>
           <a:xfrm>
             <a:off x="685800" y="1143000"/>
-            <a:ext cx="5485680" cy="3085560"/>
+            <a:ext cx="5485320" cy="3085200"/>
           </a:xfrm>
           <a:prstGeom prst="rect">
             <a:avLst/>
@@ -1467,7 +1467,7 @@
         <p:spPr>
           <a:xfrm>
             <a:off x="685800" y="4400640"/>
-            <a:ext cx="5485680" cy="3599640"/>
+            <a:ext cx="5485320" cy="3599280"/>
           </a:xfrm>
           <a:prstGeom prst="rect">
             <a:avLst/>
@@ -1501,7 +1501,7 @@
         <p:spPr>
           <a:xfrm>
             <a:off x="3884760" y="8685360"/>
-            <a:ext cx="2971080" cy="457920"/>
+            <a:ext cx="2970720" cy="457560"/>
           </a:xfrm>
           <a:prstGeom prst="rect">
             <a:avLst/>
@@ -1533,7 +1533,7 @@
               </a:lnSpc>
               <a:buNone/>
             </a:pPr>
-            <a:fld id="{5355DE01-E4E9-4146-BBC2-B811DEA0C64F}" type="slidenum">
+            <a:fld id="{B964CDF3-8549-406B-ACA8-7D5B52BADD09}" type="slidenum">
               <a:rPr b="0" lang="en-US" sz="1200" spc="-1" strike="noStrike">
                 <a:latin typeface="Times New Roman"/>
               </a:rPr>
@@ -1580,7 +1580,7 @@
         <p:spPr>
           <a:xfrm>
             <a:off x="685800" y="1143000"/>
-            <a:ext cx="5485680" cy="3085560"/>
+            <a:ext cx="5485320" cy="3085200"/>
           </a:xfrm>
           <a:prstGeom prst="rect">
             <a:avLst/>
@@ -1603,7 +1603,7 @@
         <p:spPr>
           <a:xfrm>
             <a:off x="685800" y="4400640"/>
-            <a:ext cx="5485680" cy="3599640"/>
+            <a:ext cx="5485320" cy="3599280"/>
           </a:xfrm>
           <a:prstGeom prst="rect">
             <a:avLst/>
@@ -1637,7 +1637,7 @@
         <p:spPr>
           <a:xfrm>
             <a:off x="3884760" y="8685360"/>
-            <a:ext cx="2971080" cy="457920"/>
+            <a:ext cx="2970720" cy="457560"/>
           </a:xfrm>
           <a:prstGeom prst="rect">
             <a:avLst/>
@@ -1669,7 +1669,7 @@
               </a:lnSpc>
               <a:buNone/>
             </a:pPr>
-            <a:fld id="{0DB71B61-9B00-4DE1-84D5-6C6ECBE339BC}" type="slidenum">
+            <a:fld id="{CCB524E5-97CC-42CF-90B3-6D68D835745D}" type="slidenum">
               <a:rPr b="0" lang="en-US" sz="1200" spc="-1" strike="noStrike">
                 <a:latin typeface="Times New Roman"/>
               </a:rPr>
@@ -1716,7 +1716,7 @@
         <p:spPr>
           <a:xfrm>
             <a:off x="685800" y="1143000"/>
-            <a:ext cx="5485680" cy="3085560"/>
+            <a:ext cx="5485320" cy="3085200"/>
           </a:xfrm>
           <a:prstGeom prst="rect">
             <a:avLst/>
@@ -1739,7 +1739,7 @@
         <p:spPr>
           <a:xfrm>
             <a:off x="685800" y="4400640"/>
-            <a:ext cx="5485680" cy="3599640"/>
+            <a:ext cx="5485320" cy="3599280"/>
           </a:xfrm>
           <a:prstGeom prst="rect">
             <a:avLst/>
@@ -1773,7 +1773,7 @@
         <p:spPr>
           <a:xfrm>
             <a:off x="3884760" y="8685360"/>
-            <a:ext cx="2971080" cy="457920"/>
+            <a:ext cx="2970720" cy="457560"/>
           </a:xfrm>
           <a:prstGeom prst="rect">
             <a:avLst/>
@@ -1805,7 +1805,7 @@
               </a:lnSpc>
               <a:buNone/>
             </a:pPr>
-            <a:fld id="{A57903B4-4EBF-43CA-8274-68481BB4D649}" type="slidenum">
+            <a:fld id="{87E11554-D43D-42FD-9BC7-DB04C70A5B91}" type="slidenum">
               <a:rPr b="0" lang="en-US" sz="1200" spc="-1" strike="noStrike">
                 <a:latin typeface="Times New Roman"/>
               </a:rPr>
@@ -1852,7 +1852,7 @@
         <p:spPr>
           <a:xfrm>
             <a:off x="685800" y="1143000"/>
-            <a:ext cx="5485680" cy="3085560"/>
+            <a:ext cx="5485320" cy="3085200"/>
           </a:xfrm>
           <a:prstGeom prst="rect">
             <a:avLst/>
@@ -1875,7 +1875,7 @@
         <p:spPr>
           <a:xfrm>
             <a:off x="685800" y="4400640"/>
-            <a:ext cx="5485680" cy="3599640"/>
+            <a:ext cx="5485320" cy="3599280"/>
           </a:xfrm>
           <a:prstGeom prst="rect">
             <a:avLst/>
@@ -1909,7 +1909,7 @@
         <p:spPr>
           <a:xfrm>
             <a:off x="3884760" y="8685360"/>
-            <a:ext cx="2971080" cy="457920"/>
+            <a:ext cx="2970720" cy="457560"/>
           </a:xfrm>
           <a:prstGeom prst="rect">
             <a:avLst/>
@@ -1941,7 +1941,7 @@
               </a:lnSpc>
               <a:buNone/>
             </a:pPr>
-            <a:fld id="{8EF7F12D-7AD6-48D7-AE2E-95DD1FADAC7B}" type="slidenum">
+            <a:fld id="{FBD148C5-4241-4891-95E0-B17B136803CC}" type="slidenum">
               <a:rPr b="0" lang="en-US" sz="1200" spc="-1" strike="noStrike">
                 <a:latin typeface="Times New Roman"/>
               </a:rPr>
@@ -1988,7 +1988,7 @@
         <p:spPr>
           <a:xfrm>
             <a:off x="685800" y="1143000"/>
-            <a:ext cx="5485680" cy="3085560"/>
+            <a:ext cx="5485320" cy="3085200"/>
           </a:xfrm>
           <a:prstGeom prst="rect">
             <a:avLst/>
@@ -2011,7 +2011,7 @@
         <p:spPr>
           <a:xfrm>
             <a:off x="685800" y="4400640"/>
-            <a:ext cx="5485680" cy="3599640"/>
+            <a:ext cx="5485320" cy="3599280"/>
           </a:xfrm>
           <a:prstGeom prst="rect">
             <a:avLst/>
@@ -2060,7 +2060,7 @@
         <p:spPr>
           <a:xfrm>
             <a:off x="3884760" y="8685360"/>
-            <a:ext cx="2971080" cy="457920"/>
+            <a:ext cx="2970720" cy="457560"/>
           </a:xfrm>
           <a:prstGeom prst="rect">
             <a:avLst/>
@@ -2092,7 +2092,7 @@
               </a:lnSpc>
               <a:buNone/>
             </a:pPr>
-            <a:fld id="{1BF587C8-BC82-439A-AD2F-769E35504647}" type="slidenum">
+            <a:fld id="{4C5AC5FB-2470-46C2-94A7-15FE5511BFF8}" type="slidenum">
               <a:rPr b="0" lang="en-US" sz="1200" spc="-1" strike="noStrike">
                 <a:latin typeface="Times New Roman"/>
               </a:rPr>
@@ -2139,7 +2139,7 @@
         <p:spPr>
           <a:xfrm>
             <a:off x="685800" y="1143000"/>
-            <a:ext cx="5485680" cy="3085560"/>
+            <a:ext cx="5485320" cy="3085200"/>
           </a:xfrm>
           <a:prstGeom prst="rect">
             <a:avLst/>
@@ -2162,7 +2162,7 @@
         <p:spPr>
           <a:xfrm>
             <a:off x="685800" y="4400640"/>
-            <a:ext cx="5485680" cy="3599640"/>
+            <a:ext cx="5485320" cy="3599280"/>
           </a:xfrm>
           <a:prstGeom prst="rect">
             <a:avLst/>
@@ -2196,7 +2196,7 @@
         <p:spPr>
           <a:xfrm>
             <a:off x="3884760" y="8685360"/>
-            <a:ext cx="2971080" cy="457920"/>
+            <a:ext cx="2970720" cy="457560"/>
           </a:xfrm>
           <a:prstGeom prst="rect">
             <a:avLst/>
@@ -2228,7 +2228,7 @@
               </a:lnSpc>
               <a:buNone/>
             </a:pPr>
-            <a:fld id="{0ABAFBB3-881C-4DF8-8F32-3F79B383F6DA}" type="slidenum">
+            <a:fld id="{D664E8CB-7FB9-4E32-BB2A-A0EDA2249CA6}" type="slidenum">
               <a:rPr b="0" lang="en-US" sz="1200" spc="-1" strike="noStrike">
                 <a:latin typeface="Times New Roman"/>
               </a:rPr>
@@ -2275,7 +2275,7 @@
         <p:spPr>
           <a:xfrm>
             <a:off x="685800" y="1143000"/>
-            <a:ext cx="5485680" cy="3085560"/>
+            <a:ext cx="5485320" cy="3085200"/>
           </a:xfrm>
           <a:prstGeom prst="rect">
             <a:avLst/>
@@ -2298,7 +2298,7 @@
         <p:spPr>
           <a:xfrm>
             <a:off x="685800" y="4400640"/>
-            <a:ext cx="5485680" cy="3599640"/>
+            <a:ext cx="5485320" cy="3599280"/>
           </a:xfrm>
           <a:prstGeom prst="rect">
             <a:avLst/>
@@ -2332,7 +2332,7 @@
         <p:spPr>
           <a:xfrm>
             <a:off x="3884760" y="8685360"/>
-            <a:ext cx="2971080" cy="457920"/>
+            <a:ext cx="2970720" cy="457560"/>
           </a:xfrm>
           <a:prstGeom prst="rect">
             <a:avLst/>
@@ -2364,7 +2364,7 @@
               </a:lnSpc>
               <a:buNone/>
             </a:pPr>
-            <a:fld id="{3CBFAB8E-D39C-4070-BC5C-C8946D98A59B}" type="slidenum">
+            <a:fld id="{98DCBAEC-50A5-40A9-B40B-06165BD0C92D}" type="slidenum">
               <a:rPr b="0" lang="en-US" sz="1200" spc="-1" strike="noStrike">
                 <a:latin typeface="Times New Roman"/>
               </a:rPr>
@@ -2411,7 +2411,7 @@
         <p:spPr>
           <a:xfrm>
             <a:off x="685800" y="1143000"/>
-            <a:ext cx="5485680" cy="3085560"/>
+            <a:ext cx="5485320" cy="3085200"/>
           </a:xfrm>
           <a:prstGeom prst="rect">
             <a:avLst/>
@@ -2434,7 +2434,7 @@
         <p:spPr>
           <a:xfrm>
             <a:off x="685800" y="4400640"/>
-            <a:ext cx="5485680" cy="3599640"/>
+            <a:ext cx="5485320" cy="3599280"/>
           </a:xfrm>
           <a:prstGeom prst="rect">
             <a:avLst/>
@@ -2468,7 +2468,7 @@
         <p:spPr>
           <a:xfrm>
             <a:off x="3884760" y="8685360"/>
-            <a:ext cx="2971080" cy="457920"/>
+            <a:ext cx="2970720" cy="457560"/>
           </a:xfrm>
           <a:prstGeom prst="rect">
             <a:avLst/>
@@ -2500,7 +2500,7 @@
               </a:lnSpc>
               <a:buNone/>
             </a:pPr>
-            <a:fld id="{55B3C34A-DCD6-4F5B-8BE1-44FBFD74698D}" type="slidenum">
+            <a:fld id="{DDA3C3A5-C55E-4F9E-9972-343511E2551A}" type="slidenum">
               <a:rPr b="0" lang="en-US" sz="1200" spc="-1" strike="noStrike">
                 <a:latin typeface="Times New Roman"/>
               </a:rPr>
@@ -2547,7 +2547,7 @@
         <p:spPr>
           <a:xfrm>
             <a:off x="685800" y="1143000"/>
-            <a:ext cx="5485680" cy="3085560"/>
+            <a:ext cx="5485320" cy="3085200"/>
           </a:xfrm>
           <a:prstGeom prst="rect">
             <a:avLst/>
@@ -2570,7 +2570,7 @@
         <p:spPr>
           <a:xfrm>
             <a:off x="685800" y="4400640"/>
-            <a:ext cx="5485680" cy="3599640"/>
+            <a:ext cx="5485320" cy="3599280"/>
           </a:xfrm>
           <a:prstGeom prst="rect">
             <a:avLst/>
@@ -2604,7 +2604,7 @@
         <p:spPr>
           <a:xfrm>
             <a:off x="3884760" y="8685360"/>
-            <a:ext cx="2971080" cy="457920"/>
+            <a:ext cx="2970720" cy="457560"/>
           </a:xfrm>
           <a:prstGeom prst="rect">
             <a:avLst/>
@@ -2636,7 +2636,7 @@
               </a:lnSpc>
               <a:buNone/>
             </a:pPr>
-            <a:fld id="{73D8C196-37B5-4765-BB8C-26C03B7196B1}" type="slidenum">
+            <a:fld id="{FB936CAA-1F56-4430-9B27-126D57833AA1}" type="slidenum">
               <a:rPr b="0" lang="en-US" sz="1200" spc="-1" strike="noStrike">
                 <a:latin typeface="Times New Roman"/>
               </a:rPr>
@@ -4480,7 +4480,7 @@
         <p:spPr>
           <a:xfrm>
             <a:off x="5638680" y="2266920"/>
-            <a:ext cx="913680" cy="18360"/>
+            <a:ext cx="913320" cy="18000"/>
           </a:xfrm>
           <a:custGeom>
             <a:avLst/>
@@ -4531,7 +4531,7 @@
         <p:spPr>
           <a:xfrm>
             <a:off x="3633840" y="2514600"/>
-            <a:ext cx="4923720" cy="913680"/>
+            <a:ext cx="4923360" cy="913320"/>
           </a:xfrm>
           <a:prstGeom prst="rect">
             <a:avLst/>
@@ -4559,18 +4559,18 @@
               <a:buNone/>
             </a:pPr>
             <a:r>
-              <a:rPr b="0" lang="en-US" sz="7200" spc="-182" strike="noStrike">
+              <a:rPr b="1" lang="en-US" sz="7200" spc="-182" strike="noStrike">
                 <a:solidFill>
-                  <a:srgbClr val="ffffff"/>
+                  <a:srgbClr val="000000"/>
                 </a:solidFill>
                 <a:latin typeface="Oranienbaum"/>
                 <a:ea typeface="Oranienbaum"/>
               </a:rPr>
               <a:t>Game</a:t>
             </a:r>
-            <a:endParaRPr b="0" lang="en-HK" sz="7200" spc="-1" strike="noStrike">
+            <a:endParaRPr b="1" lang="en-HK" sz="7200" spc="-1" strike="noStrike">
               <a:solidFill>
-                <a:srgbClr val="ffffff"/>
+                <a:srgbClr val="000000"/>
               </a:solidFill>
               <a:latin typeface="Arial"/>
             </a:endParaRPr>
@@ -4583,18 +4583,18 @@
               <a:buNone/>
             </a:pPr>
             <a:r>
-              <a:rPr b="0" lang="en-US" sz="7200" spc="-182" strike="noStrike">
+              <a:rPr b="1" lang="en-US" sz="7200" spc="-182" strike="noStrike">
                 <a:solidFill>
-                  <a:srgbClr val="ffffff"/>
+                  <a:srgbClr val="000000"/>
                 </a:solidFill>
                 <a:latin typeface="Oranienbaum"/>
                 <a:ea typeface="Oranienbaum"/>
               </a:rPr>
               <a:t>Theory</a:t>
             </a:r>
-            <a:endParaRPr b="0" lang="en-HK" sz="7200" spc="-1" strike="noStrike">
+            <a:endParaRPr b="1" lang="en-HK" sz="7200" spc="-1" strike="noStrike">
               <a:solidFill>
-                <a:srgbClr val="ffffff"/>
+                <a:srgbClr val="000000"/>
               </a:solidFill>
               <a:latin typeface="Arial"/>
             </a:endParaRPr>
@@ -4610,7 +4610,7 @@
         <p:spPr>
           <a:xfrm>
             <a:off x="5638680" y="3657600"/>
-            <a:ext cx="913680" cy="18360"/>
+            <a:ext cx="913320" cy="18000"/>
           </a:xfrm>
           <a:custGeom>
             <a:avLst/>
@@ -4661,7 +4661,7 @@
         <p:spPr>
           <a:xfrm>
             <a:off x="3545640" y="4286160"/>
-            <a:ext cx="5095080" cy="304200"/>
+            <a:ext cx="5094720" cy="303840"/>
           </a:xfrm>
           <a:prstGeom prst="rect">
             <a:avLst/>
@@ -4689,7 +4689,7 @@
               <a:buNone/>
             </a:pPr>
             <a:r>
-              <a:rPr b="0" lang="en-US" sz="1800" spc="41" strike="noStrike">
+              <a:rPr b="1" lang="en-US" sz="1800" spc="38" strike="noStrike">
                 <a:solidFill>
                   <a:srgbClr val="ffffff"/>
                 </a:solidFill>
@@ -4698,7 +4698,7 @@
               </a:rPr>
               <a:t>The Mathematics of Strategic Decision-Making</a:t>
             </a:r>
-            <a:endParaRPr b="0" lang="en-HK" sz="1800" spc="-1" strike="noStrike">
+            <a:endParaRPr b="1" lang="en-HK" sz="1800" spc="-1" strike="noStrike">
               <a:solidFill>
                 <a:srgbClr val="ffffff"/>
               </a:solidFill>
@@ -4753,7 +4753,7 @@
         <p:spPr>
           <a:xfrm>
             <a:off x="380880" y="380880"/>
-            <a:ext cx="11505600" cy="227880"/>
+            <a:ext cx="11505240" cy="227520"/>
           </a:xfrm>
           <a:prstGeom prst="rect">
             <a:avLst/>
@@ -4781,7 +4781,7 @@
               <a:buNone/>
             </a:pPr>
             <a:r>
-              <a:rPr b="1" lang="en-US" sz="1200" spc="55" strike="noStrike">
+              <a:rPr b="1" lang="en-US" sz="1200" spc="52" strike="noStrike">
                 <a:solidFill>
                   <a:srgbClr val="0984e3"/>
                 </a:solidFill>
@@ -4805,7 +4805,7 @@
         <p:spPr>
           <a:xfrm>
             <a:off x="380880" y="685800"/>
-            <a:ext cx="11657880" cy="456480"/>
+            <a:ext cx="11657520" cy="456120"/>
           </a:xfrm>
           <a:prstGeom prst="rect">
             <a:avLst/>
@@ -4857,7 +4857,7 @@
         <p:spPr>
           <a:xfrm>
             <a:off x="380880" y="1419120"/>
-            <a:ext cx="5496480" cy="828000"/>
+            <a:ext cx="5496120" cy="827640"/>
           </a:xfrm>
           <a:prstGeom prst="rect">
             <a:avLst/>
@@ -4909,7 +4909,7 @@
         <p:spPr>
           <a:xfrm>
             <a:off x="380880" y="2452680"/>
-            <a:ext cx="5647680" cy="837360"/>
+            <a:ext cx="5647320" cy="837000"/>
           </a:xfrm>
           <a:prstGeom prst="rect">
             <a:avLst/>
@@ -4961,7 +4961,7 @@
         <p:spPr>
           <a:xfrm>
             <a:off x="380880" y="3867120"/>
-            <a:ext cx="5562000" cy="2018520"/>
+            <a:ext cx="5561640" cy="2018160"/>
           </a:xfrm>
           <a:custGeom>
             <a:avLst/>
@@ -5012,7 +5012,7 @@
         <p:spPr>
           <a:xfrm>
             <a:off x="609480" y="4095720"/>
-            <a:ext cx="5199840" cy="266040"/>
+            <a:ext cx="5199480" cy="265680"/>
           </a:xfrm>
           <a:prstGeom prst="rect">
             <a:avLst/>
@@ -5064,7 +5064,7 @@
         <p:spPr>
           <a:xfrm>
             <a:off x="609480" y="4476600"/>
-            <a:ext cx="5180760" cy="246960"/>
+            <a:ext cx="5180400" cy="246600"/>
           </a:xfrm>
           <a:prstGeom prst="rect">
             <a:avLst/>
@@ -5156,7 +5156,7 @@
         <p:spPr>
           <a:xfrm>
             <a:off x="609480" y="4838760"/>
-            <a:ext cx="5104800" cy="456480"/>
+            <a:ext cx="5104440" cy="456120"/>
           </a:xfrm>
           <a:custGeom>
             <a:avLst/>
@@ -5207,24 +5207,24 @@
         <p:spPr>
           <a:xfrm>
             <a:off x="609480" y="4838760"/>
-            <a:ext cx="5180760" cy="456480"/>
-          </a:xfrm>
-          <a:prstGeom prst="rect">
-            <a:avLst/>
-          </a:prstGeom>
-          <a:noFill/>
-          <a:ln w="0">
-            <a:noFill/>
-          </a:ln>
-        </p:spPr>
-        <p:style>
-          <a:lnRef idx="0"/>
-          <a:fillRef idx="0"/>
-          <a:effectRef idx="0"/>
-          <a:fontRef idx="minor"/>
-        </p:style>
-        <p:txBody>
-          <a:bodyPr lIns="114480" rIns="114480" tIns="457200" bIns="457200" anchor="ctr">
+            <a:ext cx="5180400" cy="456120"/>
+          </a:xfrm>
+          <a:prstGeom prst="rect">
+            <a:avLst/>
+          </a:prstGeom>
+          <a:noFill/>
+          <a:ln w="0">
+            <a:noFill/>
+          </a:ln>
+        </p:spPr>
+        <p:style>
+          <a:lnRef idx="0"/>
+          <a:fillRef idx="0"/>
+          <a:effectRef idx="0"/>
+          <a:fontRef idx="minor"/>
+        </p:style>
+        <p:txBody>
+          <a:bodyPr lIns="114480" rIns="114480" tIns="456480" bIns="456480" anchor="ctr">
             <a:noAutofit/>
           </a:bodyPr>
           <a:p>
@@ -5259,7 +5259,7 @@
         <p:spPr>
           <a:xfrm>
             <a:off x="609480" y="5410080"/>
-            <a:ext cx="5180760" cy="246960"/>
+            <a:ext cx="5180400" cy="246600"/>
           </a:xfrm>
           <a:prstGeom prst="rect">
             <a:avLst/>
@@ -5331,7 +5331,7 @@
         <p:spPr>
           <a:xfrm>
             <a:off x="6253200" y="1376280"/>
-            <a:ext cx="5552280" cy="3209040"/>
+            <a:ext cx="5551920" cy="3208680"/>
           </a:xfrm>
           <a:custGeom>
             <a:avLst/>
@@ -5385,7 +5385,7 @@
         <p:spPr>
           <a:xfrm>
             <a:off x="6486480" y="1609560"/>
-            <a:ext cx="5180760" cy="266040"/>
+            <a:ext cx="5180400" cy="265680"/>
           </a:xfrm>
           <a:prstGeom prst="rect">
             <a:avLst/>
@@ -5437,7 +5437,7 @@
         <p:spPr>
           <a:xfrm>
             <a:off x="6486480" y="2028960"/>
-            <a:ext cx="304200" cy="304200"/>
+            <a:ext cx="303840" cy="303840"/>
           </a:xfrm>
           <a:custGeom>
             <a:avLst/>
@@ -5488,7 +5488,7 @@
         <p:spPr>
           <a:xfrm>
             <a:off x="6453360" y="2028960"/>
-            <a:ext cx="370800" cy="304200"/>
+            <a:ext cx="370440" cy="303840"/>
           </a:xfrm>
           <a:prstGeom prst="rect">
             <a:avLst/>
@@ -5540,7 +5540,7 @@
         <p:spPr>
           <a:xfrm>
             <a:off x="6905520" y="2028960"/>
-            <a:ext cx="3066480" cy="227880"/>
+            <a:ext cx="3066120" cy="227520"/>
           </a:xfrm>
           <a:prstGeom prst="rect">
             <a:avLst/>
@@ -5592,7 +5592,7 @@
         <p:spPr>
           <a:xfrm>
             <a:off x="6905520" y="2295360"/>
-            <a:ext cx="3066480" cy="227880"/>
+            <a:ext cx="3066120" cy="227520"/>
           </a:xfrm>
           <a:prstGeom prst="rect">
             <a:avLst/>
@@ -5644,7 +5644,7 @@
         <p:spPr>
           <a:xfrm>
             <a:off x="6486480" y="2638440"/>
-            <a:ext cx="304200" cy="304200"/>
+            <a:ext cx="303840" cy="303840"/>
           </a:xfrm>
           <a:custGeom>
             <a:avLst/>
@@ -5695,7 +5695,7 @@
         <p:spPr>
           <a:xfrm>
             <a:off x="6453360" y="2638440"/>
-            <a:ext cx="370800" cy="304200"/>
+            <a:ext cx="370440" cy="303840"/>
           </a:xfrm>
           <a:prstGeom prst="rect">
             <a:avLst/>
@@ -5747,7 +5747,7 @@
         <p:spPr>
           <a:xfrm>
             <a:off x="6905520" y="2638440"/>
-            <a:ext cx="3666240" cy="227880"/>
+            <a:ext cx="3665880" cy="227520"/>
           </a:xfrm>
           <a:prstGeom prst="rect">
             <a:avLst/>
@@ -5799,7 +5799,7 @@
         <p:spPr>
           <a:xfrm>
             <a:off x="6905520" y="2905200"/>
-            <a:ext cx="3666240" cy="227880"/>
+            <a:ext cx="3665880" cy="227520"/>
           </a:xfrm>
           <a:prstGeom prst="rect">
             <a:avLst/>
@@ -5851,7 +5851,7 @@
         <p:spPr>
           <a:xfrm>
             <a:off x="6486480" y="3247920"/>
-            <a:ext cx="304200" cy="304200"/>
+            <a:ext cx="303840" cy="303840"/>
           </a:xfrm>
           <a:custGeom>
             <a:avLst/>
@@ -5902,7 +5902,7 @@
         <p:spPr>
           <a:xfrm>
             <a:off x="6453360" y="3247920"/>
-            <a:ext cx="370800" cy="304200"/>
+            <a:ext cx="370440" cy="303840"/>
           </a:xfrm>
           <a:prstGeom prst="rect">
             <a:avLst/>
@@ -5954,7 +5954,7 @@
         <p:spPr>
           <a:xfrm>
             <a:off x="6905520" y="3247920"/>
-            <a:ext cx="3285360" cy="227880"/>
+            <a:ext cx="3285000" cy="227520"/>
           </a:xfrm>
           <a:prstGeom prst="rect">
             <a:avLst/>
@@ -6006,7 +6006,7 @@
         <p:spPr>
           <a:xfrm>
             <a:off x="6905520" y="3514680"/>
-            <a:ext cx="3285360" cy="227880"/>
+            <a:ext cx="3285000" cy="227520"/>
           </a:xfrm>
           <a:prstGeom prst="rect">
             <a:avLst/>
@@ -6058,7 +6058,7 @@
         <p:spPr>
           <a:xfrm>
             <a:off x="6486480" y="3857760"/>
-            <a:ext cx="304200" cy="304200"/>
+            <a:ext cx="303840" cy="303840"/>
           </a:xfrm>
           <a:custGeom>
             <a:avLst/>
@@ -6109,7 +6109,7 @@
         <p:spPr>
           <a:xfrm>
             <a:off x="6453360" y="3857760"/>
-            <a:ext cx="370800" cy="304200"/>
+            <a:ext cx="370440" cy="303840"/>
           </a:xfrm>
           <a:prstGeom prst="rect">
             <a:avLst/>
@@ -6161,7 +6161,7 @@
         <p:spPr>
           <a:xfrm>
             <a:off x="6905520" y="3857760"/>
-            <a:ext cx="4133160" cy="227880"/>
+            <a:ext cx="4132800" cy="227520"/>
           </a:xfrm>
           <a:prstGeom prst="rect">
             <a:avLst/>
@@ -6213,7 +6213,7 @@
         <p:spPr>
           <a:xfrm>
             <a:off x="6905520" y="4124160"/>
-            <a:ext cx="4133160" cy="227880"/>
+            <a:ext cx="4132800" cy="227520"/>
           </a:xfrm>
           <a:prstGeom prst="rect">
             <a:avLst/>
@@ -6265,7 +6265,7 @@
         <p:spPr>
           <a:xfrm>
             <a:off x="6267600" y="4743360"/>
-            <a:ext cx="5542920" cy="1142280"/>
+            <a:ext cx="5542560" cy="1141920"/>
           </a:xfrm>
           <a:custGeom>
             <a:avLst/>
@@ -6316,7 +6316,7 @@
         <p:spPr>
           <a:xfrm>
             <a:off x="6267600" y="4743360"/>
-            <a:ext cx="37440" cy="1142280"/>
+            <a:ext cx="37080" cy="1141920"/>
           </a:xfrm>
           <a:custGeom>
             <a:avLst/>
@@ -6367,7 +6367,7 @@
         <p:spPr>
           <a:xfrm>
             <a:off x="6477120" y="4933800"/>
-            <a:ext cx="5218920" cy="494640"/>
+            <a:ext cx="5218560" cy="494280"/>
           </a:xfrm>
           <a:prstGeom prst="rect">
             <a:avLst/>
@@ -6419,7 +6419,7 @@
         <p:spPr>
           <a:xfrm>
             <a:off x="6477120" y="5505480"/>
-            <a:ext cx="5209560" cy="189720"/>
+            <a:ext cx="5209200" cy="189360"/>
           </a:xfrm>
           <a:prstGeom prst="rect">
             <a:avLst/>
@@ -6518,7 +6518,7 @@
         <p:spPr>
           <a:xfrm>
             <a:off x="379440" y="379440"/>
-            <a:ext cx="11508120" cy="227160"/>
+            <a:ext cx="11507760" cy="226800"/>
           </a:xfrm>
           <a:prstGeom prst="rect">
             <a:avLst/>
@@ -6546,7 +6546,7 @@
               <a:buNone/>
             </a:pPr>
             <a:r>
-              <a:rPr b="1" lang="en-US" sz="1200" spc="55" strike="noStrike">
+              <a:rPr b="1" lang="en-US" sz="1200" spc="52" strike="noStrike">
                 <a:solidFill>
                   <a:srgbClr val="0984e3"/>
                 </a:solidFill>
@@ -6570,7 +6570,7 @@
         <p:spPr>
           <a:xfrm>
             <a:off x="379440" y="683280"/>
-            <a:ext cx="11660040" cy="454680"/>
+            <a:ext cx="11659680" cy="454320"/>
           </a:xfrm>
           <a:prstGeom prst="rect">
             <a:avLst/>
@@ -6622,7 +6622,7 @@
         <p:spPr>
           <a:xfrm>
             <a:off x="379440" y="1366200"/>
-            <a:ext cx="5682600" cy="302760"/>
+            <a:ext cx="5682240" cy="302400"/>
           </a:xfrm>
           <a:prstGeom prst="rect">
             <a:avLst/>
@@ -6674,7 +6674,7 @@
         <p:spPr>
           <a:xfrm>
             <a:off x="379440" y="1826280"/>
-            <a:ext cx="5096520" cy="466560"/>
+            <a:ext cx="5096160" cy="466200"/>
           </a:xfrm>
           <a:prstGeom prst="rect">
             <a:avLst/>
@@ -6726,7 +6726,7 @@
         <p:spPr>
           <a:xfrm>
             <a:off x="379440" y="2452680"/>
-            <a:ext cx="5644440" cy="739440"/>
+            <a:ext cx="5644080" cy="739080"/>
           </a:xfrm>
           <a:prstGeom prst="rect">
             <a:avLst/>
@@ -6778,7 +6778,7 @@
         <p:spPr>
           <a:xfrm>
             <a:off x="398520" y="3306600"/>
-            <a:ext cx="5549760" cy="758160"/>
+            <a:ext cx="5549400" cy="757800"/>
           </a:xfrm>
           <a:custGeom>
             <a:avLst/>
@@ -6829,7 +6829,7 @@
         <p:spPr>
           <a:xfrm>
             <a:off x="398520" y="3306600"/>
-            <a:ext cx="37080" cy="758160"/>
+            <a:ext cx="36720" cy="757800"/>
           </a:xfrm>
           <a:custGeom>
             <a:avLst/>
@@ -6880,7 +6880,7 @@
         <p:spPr>
           <a:xfrm>
             <a:off x="569160" y="3458520"/>
-            <a:ext cx="5303160" cy="454680"/>
+            <a:ext cx="5302800" cy="454320"/>
           </a:xfrm>
           <a:prstGeom prst="rect">
             <a:avLst/>
@@ -6973,7 +6973,7 @@
         <p:spPr>
           <a:xfrm>
             <a:off x="379440" y="4217400"/>
-            <a:ext cx="5682600" cy="302760"/>
+            <a:ext cx="5682240" cy="302400"/>
           </a:xfrm>
           <a:prstGeom prst="rect">
             <a:avLst/>
@@ -7025,7 +7025,7 @@
         <p:spPr>
           <a:xfrm>
             <a:off x="379440" y="4635000"/>
-            <a:ext cx="5644440" cy="739440"/>
+            <a:ext cx="5644080" cy="739080"/>
           </a:xfrm>
           <a:prstGeom prst="rect">
             <a:avLst/>
@@ -7077,7 +7077,7 @@
         <p:spPr>
           <a:xfrm>
             <a:off x="6249240" y="1366200"/>
-            <a:ext cx="5682600" cy="302760"/>
+            <a:ext cx="5682240" cy="302400"/>
           </a:xfrm>
           <a:prstGeom prst="rect">
             <a:avLst/>
@@ -7129,7 +7129,7 @@
         <p:spPr>
           <a:xfrm>
             <a:off x="6249240" y="1826280"/>
-            <a:ext cx="5249880" cy="466560"/>
+            <a:ext cx="5249520" cy="466200"/>
           </a:xfrm>
           <a:prstGeom prst="rect">
             <a:avLst/>
@@ -7181,7 +7181,7 @@
         <p:spPr>
           <a:xfrm>
             <a:off x="6249240" y="2452680"/>
-            <a:ext cx="5644440" cy="739440"/>
+            <a:ext cx="5644080" cy="739080"/>
           </a:xfrm>
           <a:prstGeom prst="rect">
             <a:avLst/>
@@ -7233,7 +7233,7 @@
         <p:spPr>
           <a:xfrm>
             <a:off x="6249240" y="3344400"/>
-            <a:ext cx="5568840" cy="2181600"/>
+            <a:ext cx="5568480" cy="2181240"/>
           </a:xfrm>
           <a:custGeom>
             <a:avLst/>
@@ -7284,7 +7284,7 @@
         <p:spPr>
           <a:xfrm>
             <a:off x="6438960" y="3534120"/>
-            <a:ext cx="5284080" cy="264960"/>
+            <a:ext cx="5283720" cy="264600"/>
           </a:xfrm>
           <a:prstGeom prst="rect">
             <a:avLst/>
@@ -7336,7 +7336,7 @@
         <p:spPr>
           <a:xfrm>
             <a:off x="6438960" y="3913920"/>
-            <a:ext cx="5265000" cy="245880"/>
+            <a:ext cx="5264640" cy="245520"/>
           </a:xfrm>
           <a:prstGeom prst="rect">
             <a:avLst/>
@@ -7388,7 +7388,7 @@
         <p:spPr>
           <a:xfrm>
             <a:off x="6438960" y="4274280"/>
-            <a:ext cx="5189040" cy="454680"/>
+            <a:ext cx="5188680" cy="454320"/>
           </a:xfrm>
           <a:custGeom>
             <a:avLst/>
@@ -7439,24 +7439,24 @@
         <p:spPr>
           <a:xfrm>
             <a:off x="6438960" y="4274280"/>
-            <a:ext cx="5265000" cy="454680"/>
-          </a:xfrm>
-          <a:prstGeom prst="rect">
-            <a:avLst/>
-          </a:prstGeom>
-          <a:noFill/>
-          <a:ln w="0">
-            <a:noFill/>
-          </a:ln>
-        </p:spPr>
-        <p:style>
-          <a:lnRef idx="0"/>
-          <a:fillRef idx="0"/>
-          <a:effectRef idx="0"/>
-          <a:fontRef idx="minor"/>
-        </p:style>
-        <p:txBody>
-          <a:bodyPr lIns="113760" rIns="113760" tIns="113760" bIns="113760" anchor="ctr">
+            <a:ext cx="5264640" cy="454320"/>
+          </a:xfrm>
+          <a:prstGeom prst="rect">
+            <a:avLst/>
+          </a:prstGeom>
+          <a:noFill/>
+          <a:ln w="0">
+            <a:noFill/>
+          </a:ln>
+        </p:spPr>
+        <p:style>
+          <a:lnRef idx="0"/>
+          <a:fillRef idx="0"/>
+          <a:effectRef idx="0"/>
+          <a:fontRef idx="minor"/>
+        </p:style>
+        <p:txBody>
+          <a:bodyPr lIns="113760" rIns="113760" tIns="227520" bIns="227520" anchor="ctr">
             <a:noAutofit/>
           </a:bodyPr>
           <a:p>
@@ -7491,7 +7491,7 @@
         <p:spPr>
           <a:xfrm>
             <a:off x="6438960" y="4843440"/>
-            <a:ext cx="5265000" cy="492480"/>
+            <a:ext cx="5264640" cy="492120"/>
           </a:xfrm>
           <a:prstGeom prst="rect">
             <a:avLst/>
@@ -7543,7 +7543,7 @@
         <p:spPr>
           <a:xfrm>
             <a:off x="6268320" y="5678640"/>
-            <a:ext cx="5549760" cy="796320"/>
+            <a:ext cx="5549400" cy="795960"/>
           </a:xfrm>
           <a:custGeom>
             <a:avLst/>
@@ -7594,7 +7594,7 @@
         <p:spPr>
           <a:xfrm>
             <a:off x="6268320" y="5678640"/>
-            <a:ext cx="37080" cy="796320"/>
+            <a:ext cx="36720" cy="795960"/>
           </a:xfrm>
           <a:custGeom>
             <a:avLst/>
@@ -7645,7 +7645,7 @@
         <p:spPr>
           <a:xfrm>
             <a:off x="6438960" y="5830200"/>
-            <a:ext cx="5303160" cy="492480"/>
+            <a:ext cx="5302800" cy="492120"/>
           </a:xfrm>
           <a:prstGeom prst="rect">
             <a:avLst/>
@@ -7744,7 +7744,7 @@
         <p:spPr>
           <a:xfrm>
             <a:off x="609480" y="2066760"/>
-            <a:ext cx="12191400" cy="1218600"/>
+            <a:ext cx="12191040" cy="1218240"/>
           </a:xfrm>
           <a:prstGeom prst="rect">
             <a:avLst/>
@@ -7798,7 +7798,7 @@
         <p:spPr>
           <a:xfrm>
             <a:off x="609480" y="3438360"/>
-            <a:ext cx="11867400" cy="570960"/>
+            <a:ext cx="11867040" cy="570600"/>
           </a:xfrm>
           <a:prstGeom prst="rect">
             <a:avLst/>
@@ -7850,7 +7850,7 @@
         <p:spPr>
           <a:xfrm>
             <a:off x="609480" y="4238640"/>
-            <a:ext cx="1218600" cy="18360"/>
+            <a:ext cx="1218240" cy="18000"/>
           </a:xfrm>
           <a:custGeom>
             <a:avLst/>
@@ -7901,7 +7901,7 @@
         <p:spPr>
           <a:xfrm>
             <a:off x="609480" y="4486320"/>
-            <a:ext cx="11696040" cy="304200"/>
+            <a:ext cx="11695680" cy="303840"/>
           </a:xfrm>
           <a:prstGeom prst="rect">
             <a:avLst/>
@@ -7990,7 +7990,7 @@
         <p:spPr>
           <a:xfrm>
             <a:off x="356400" y="356400"/>
-            <a:ext cx="11550240" cy="213120"/>
+            <a:ext cx="11549880" cy="212760"/>
           </a:xfrm>
           <a:prstGeom prst="rect">
             <a:avLst/>
@@ -8018,7 +8018,7 @@
               <a:buNone/>
             </a:pPr>
             <a:r>
-              <a:rPr b="1" lang="en-US" sz="1120" spc="52" strike="noStrike">
+              <a:rPr b="1" lang="en-US" sz="1120" spc="49" strike="noStrike">
                 <a:solidFill>
                   <a:srgbClr val="0984e3"/>
                 </a:solidFill>
@@ -8042,7 +8042,7 @@
         <p:spPr>
           <a:xfrm>
             <a:off x="356400" y="641160"/>
-            <a:ext cx="11692440" cy="426600"/>
+            <a:ext cx="11692080" cy="426240"/>
           </a:xfrm>
           <a:prstGeom prst="rect">
             <a:avLst/>
@@ -8094,7 +8094,7 @@
         <p:spPr>
           <a:xfrm>
             <a:off x="360720" y="1287000"/>
-            <a:ext cx="3695040" cy="2626560"/>
+            <a:ext cx="3694680" cy="2626200"/>
           </a:xfrm>
           <a:custGeom>
             <a:avLst/>
@@ -8148,7 +8148,7 @@
         <p:spPr>
           <a:xfrm>
             <a:off x="543240" y="1469520"/>
-            <a:ext cx="426600" cy="426600"/>
+            <a:ext cx="426240" cy="426240"/>
           </a:xfrm>
           <a:custGeom>
             <a:avLst/>
@@ -8199,7 +8199,7 @@
         <p:spPr>
           <a:xfrm>
             <a:off x="656640" y="1594080"/>
-            <a:ext cx="199800" cy="177480"/>
+            <a:ext cx="199440" cy="177120"/>
           </a:xfrm>
           <a:custGeom>
             <a:avLst/>
@@ -8396,7 +8396,7 @@
         <p:spPr>
           <a:xfrm>
             <a:off x="1077480" y="1558440"/>
-            <a:ext cx="2341440" cy="248760"/>
+            <a:ext cx="2341080" cy="248400"/>
           </a:xfrm>
           <a:prstGeom prst="rect">
             <a:avLst/>
@@ -8448,7 +8448,7 @@
         <p:spPr>
           <a:xfrm>
             <a:off x="543240" y="2003760"/>
-            <a:ext cx="3401280" cy="694080"/>
+            <a:ext cx="3400920" cy="693720"/>
           </a:xfrm>
           <a:prstGeom prst="rect">
             <a:avLst/>
@@ -8510,7 +8510,7 @@
         <p:spPr>
           <a:xfrm>
             <a:off x="543240" y="2805480"/>
-            <a:ext cx="3401280" cy="925560"/>
+            <a:ext cx="3400920" cy="925200"/>
           </a:xfrm>
           <a:prstGeom prst="rect">
             <a:avLst/>
@@ -8572,7 +8572,7 @@
         <p:spPr>
           <a:xfrm>
             <a:off x="4246200" y="1287000"/>
-            <a:ext cx="3695040" cy="2626560"/>
+            <a:ext cx="3694680" cy="2626200"/>
           </a:xfrm>
           <a:custGeom>
             <a:avLst/>
@@ -8626,7 +8626,7 @@
         <p:spPr>
           <a:xfrm>
             <a:off x="4428720" y="1469520"/>
-            <a:ext cx="426600" cy="426600"/>
+            <a:ext cx="426240" cy="426240"/>
           </a:xfrm>
           <a:custGeom>
             <a:avLst/>
@@ -8677,7 +8677,7 @@
         <p:spPr>
           <a:xfrm>
             <a:off x="4542120" y="1594080"/>
-            <a:ext cx="199800" cy="177480"/>
+            <a:ext cx="199440" cy="177120"/>
           </a:xfrm>
           <a:custGeom>
             <a:avLst/>
@@ -8829,7 +8829,7 @@
         <p:spPr>
           <a:xfrm>
             <a:off x="4962960" y="1558440"/>
-            <a:ext cx="2430720" cy="248760"/>
+            <a:ext cx="2430360" cy="248400"/>
           </a:xfrm>
           <a:prstGeom prst="rect">
             <a:avLst/>
@@ -8881,7 +8881,7 @@
         <p:spPr>
           <a:xfrm>
             <a:off x="4428720" y="2003760"/>
-            <a:ext cx="3401280" cy="694080"/>
+            <a:ext cx="3400920" cy="693720"/>
           </a:xfrm>
           <a:prstGeom prst="rect">
             <a:avLst/>
@@ -8943,7 +8943,7 @@
         <p:spPr>
           <a:xfrm>
             <a:off x="4428720" y="2805480"/>
-            <a:ext cx="3401280" cy="694080"/>
+            <a:ext cx="3400920" cy="693720"/>
           </a:xfrm>
           <a:prstGeom prst="rect">
             <a:avLst/>
@@ -9005,7 +9005,7 @@
         <p:spPr>
           <a:xfrm>
             <a:off x="8131680" y="1287000"/>
-            <a:ext cx="3695040" cy="2626560"/>
+            <a:ext cx="3694680" cy="2626200"/>
           </a:xfrm>
           <a:custGeom>
             <a:avLst/>
@@ -9059,7 +9059,7 @@
         <p:spPr>
           <a:xfrm>
             <a:off x="8314200" y="1469520"/>
-            <a:ext cx="426600" cy="426600"/>
+            <a:ext cx="426240" cy="426240"/>
           </a:xfrm>
           <a:custGeom>
             <a:avLst/>
@@ -9110,7 +9110,7 @@
         <p:spPr>
           <a:xfrm>
             <a:off x="8439120" y="1594080"/>
-            <a:ext cx="177480" cy="177480"/>
+            <a:ext cx="177120" cy="177120"/>
           </a:xfrm>
           <a:custGeom>
             <a:avLst/>
@@ -9210,7 +9210,7 @@
         <p:spPr>
           <a:xfrm>
             <a:off x="8848800" y="1558440"/>
-            <a:ext cx="2038680" cy="248760"/>
+            <a:ext cx="2038320" cy="248400"/>
           </a:xfrm>
           <a:prstGeom prst="rect">
             <a:avLst/>
@@ -9262,7 +9262,7 @@
         <p:spPr>
           <a:xfrm>
             <a:off x="8314200" y="2003760"/>
-            <a:ext cx="3401280" cy="694080"/>
+            <a:ext cx="3400920" cy="693720"/>
           </a:xfrm>
           <a:prstGeom prst="rect">
             <a:avLst/>
@@ -9324,7 +9324,7 @@
         <p:spPr>
           <a:xfrm>
             <a:off x="8314200" y="2805480"/>
-            <a:ext cx="3401280" cy="694080"/>
+            <a:ext cx="3400920" cy="693720"/>
           </a:xfrm>
           <a:prstGeom prst="rect">
             <a:avLst/>
@@ -9386,7 +9386,7 @@
         <p:spPr>
           <a:xfrm>
             <a:off x="360720" y="4101120"/>
-            <a:ext cx="3695040" cy="2395080"/>
+            <a:ext cx="3694680" cy="2394720"/>
           </a:xfrm>
           <a:custGeom>
             <a:avLst/>
@@ -9440,7 +9440,7 @@
         <p:spPr>
           <a:xfrm>
             <a:off x="543240" y="4283640"/>
-            <a:ext cx="426600" cy="426600"/>
+            <a:ext cx="426240" cy="426240"/>
           </a:xfrm>
           <a:custGeom>
             <a:avLst/>
@@ -9491,7 +9491,7 @@
         <p:spPr>
           <a:xfrm>
             <a:off x="645840" y="4408200"/>
-            <a:ext cx="221760" cy="177480"/>
+            <a:ext cx="221400" cy="177120"/>
           </a:xfrm>
           <a:custGeom>
             <a:avLst/>
@@ -9723,7 +9723,7 @@
         <p:spPr>
           <a:xfrm>
             <a:off x="1077480" y="4372560"/>
-            <a:ext cx="1931760" cy="248760"/>
+            <a:ext cx="1931400" cy="248400"/>
           </a:xfrm>
           <a:prstGeom prst="rect">
             <a:avLst/>
@@ -9775,7 +9775,7 @@
         <p:spPr>
           <a:xfrm>
             <a:off x="543240" y="4817880"/>
-            <a:ext cx="3401280" cy="694080"/>
+            <a:ext cx="3400920" cy="693720"/>
           </a:xfrm>
           <a:prstGeom prst="rect">
             <a:avLst/>
@@ -9837,7 +9837,7 @@
         <p:spPr>
           <a:xfrm>
             <a:off x="543240" y="5619600"/>
-            <a:ext cx="3401280" cy="694080"/>
+            <a:ext cx="3400920" cy="693720"/>
           </a:xfrm>
           <a:prstGeom prst="rect">
             <a:avLst/>
@@ -9899,7 +9899,7 @@
         <p:spPr>
           <a:xfrm>
             <a:off x="4246200" y="4101120"/>
-            <a:ext cx="7587000" cy="2395080"/>
+            <a:ext cx="7586640" cy="2394720"/>
           </a:xfrm>
           <a:custGeom>
             <a:avLst/>
@@ -9953,7 +9953,7 @@
         <p:spPr>
           <a:xfrm>
             <a:off x="4428720" y="4283640"/>
-            <a:ext cx="426600" cy="426600"/>
+            <a:ext cx="426240" cy="426240"/>
           </a:xfrm>
           <a:custGeom>
             <a:avLst/>
@@ -10004,7 +10004,7 @@
         <p:spPr>
           <a:xfrm>
             <a:off x="4553280" y="4408200"/>
-            <a:ext cx="177480" cy="177480"/>
+            <a:ext cx="177120" cy="177120"/>
           </a:xfrm>
           <a:custGeom>
             <a:avLst/>
@@ -10137,7 +10137,7 @@
         <p:spPr>
           <a:xfrm>
             <a:off x="4962960" y="4372560"/>
-            <a:ext cx="2047680" cy="248760"/>
+            <a:ext cx="2047320" cy="248400"/>
           </a:xfrm>
           <a:prstGeom prst="rect">
             <a:avLst/>
@@ -10189,7 +10189,7 @@
         <p:spPr>
           <a:xfrm>
             <a:off x="4428720" y="4817880"/>
-            <a:ext cx="3606120" cy="694080"/>
+            <a:ext cx="3605760" cy="693720"/>
           </a:xfrm>
           <a:prstGeom prst="rect">
             <a:avLst/>
@@ -10251,7 +10251,7 @@
         <p:spPr>
           <a:xfrm>
             <a:off x="4428720" y="5583960"/>
-            <a:ext cx="3606120" cy="462240"/>
+            <a:ext cx="3605760" cy="461880"/>
           </a:xfrm>
           <a:prstGeom prst="rect">
             <a:avLst/>
@@ -10303,7 +10303,7 @@
         <p:spPr>
           <a:xfrm>
             <a:off x="8109360" y="4817880"/>
-            <a:ext cx="3606120" cy="694080"/>
+            <a:ext cx="3605760" cy="693720"/>
           </a:xfrm>
           <a:prstGeom prst="rect">
             <a:avLst/>
@@ -10365,7 +10365,7 @@
         <p:spPr>
           <a:xfrm>
             <a:off x="8109360" y="5583960"/>
-            <a:ext cx="3606120" cy="462240"/>
+            <a:ext cx="3605760" cy="461880"/>
           </a:xfrm>
           <a:prstGeom prst="rect">
             <a:avLst/>
@@ -10454,7 +10454,7 @@
         <p:spPr>
           <a:xfrm>
             <a:off x="609480" y="2066760"/>
-            <a:ext cx="12191400" cy="1218600"/>
+            <a:ext cx="12191040" cy="1218240"/>
           </a:xfrm>
           <a:prstGeom prst="rect">
             <a:avLst/>
@@ -10508,7 +10508,7 @@
         <p:spPr>
           <a:xfrm>
             <a:off x="609480" y="3438360"/>
-            <a:ext cx="11867400" cy="570960"/>
+            <a:ext cx="11867040" cy="570600"/>
           </a:xfrm>
           <a:prstGeom prst="rect">
             <a:avLst/>
@@ -10560,7 +10560,7 @@
         <p:spPr>
           <a:xfrm>
             <a:off x="609480" y="4238640"/>
-            <a:ext cx="1218600" cy="18360"/>
+            <a:ext cx="1218240" cy="18000"/>
           </a:xfrm>
           <a:custGeom>
             <a:avLst/>
@@ -10611,7 +10611,7 @@
         <p:spPr>
           <a:xfrm>
             <a:off x="609480" y="4486320"/>
-            <a:ext cx="11696040" cy="304200"/>
+            <a:ext cx="11695680" cy="303840"/>
           </a:xfrm>
           <a:prstGeom prst="rect">
             <a:avLst/>
@@ -10700,7 +10700,7 @@
         <p:spPr>
           <a:xfrm>
             <a:off x="380880" y="380880"/>
-            <a:ext cx="11505600" cy="227880"/>
+            <a:ext cx="11505240" cy="227520"/>
           </a:xfrm>
           <a:prstGeom prst="rect">
             <a:avLst/>
@@ -10728,7 +10728,7 @@
               <a:buNone/>
             </a:pPr>
             <a:r>
-              <a:rPr b="1" lang="en-US" sz="1200" spc="55" strike="noStrike">
+              <a:rPr b="1" lang="en-US" sz="1200" spc="52" strike="noStrike">
                 <a:solidFill>
                   <a:srgbClr val="0984e3"/>
                 </a:solidFill>
@@ -10752,7 +10752,7 @@
         <p:spPr>
           <a:xfrm>
             <a:off x="380880" y="685800"/>
-            <a:ext cx="11657880" cy="456480"/>
+            <a:ext cx="11657520" cy="456120"/>
           </a:xfrm>
           <a:prstGeom prst="rect">
             <a:avLst/>
@@ -10804,7 +10804,7 @@
         <p:spPr>
           <a:xfrm>
             <a:off x="380880" y="1295280"/>
-            <a:ext cx="5657040" cy="1237680"/>
+            <a:ext cx="5656680" cy="1237320"/>
           </a:xfrm>
           <a:prstGeom prst="rect">
             <a:avLst/>
@@ -10866,7 +10866,7 @@
         <p:spPr>
           <a:xfrm>
             <a:off x="380880" y="2647800"/>
-            <a:ext cx="5637960" cy="742320"/>
+            <a:ext cx="5637600" cy="741960"/>
           </a:xfrm>
           <a:prstGeom prst="rect">
             <a:avLst/>
@@ -10918,7 +10918,7 @@
         <p:spPr>
           <a:xfrm>
             <a:off x="385920" y="3548160"/>
-            <a:ext cx="5552280" cy="2028240"/>
+            <a:ext cx="5551920" cy="2027880"/>
           </a:xfrm>
           <a:custGeom>
             <a:avLst/>
@@ -10972,7 +10972,7 @@
         <p:spPr>
           <a:xfrm>
             <a:off x="495360" y="3705120"/>
-            <a:ext cx="5333400" cy="266040"/>
+            <a:ext cx="5333040" cy="265680"/>
           </a:xfrm>
           <a:prstGeom prst="rect">
             <a:avLst/>
@@ -11498,7 +11498,7 @@
         <p:spPr>
           <a:xfrm>
             <a:off x="509760" y="5229360"/>
-            <a:ext cx="5304600" cy="189720"/>
+            <a:ext cx="5304240" cy="189360"/>
           </a:xfrm>
           <a:prstGeom prst="rect">
             <a:avLst/>
@@ -11550,7 +11550,7 @@
         <p:spPr>
           <a:xfrm>
             <a:off x="6253200" y="1300320"/>
-            <a:ext cx="5552280" cy="1608840"/>
+            <a:ext cx="5551920" cy="1608480"/>
           </a:xfrm>
           <a:custGeom>
             <a:avLst/>
@@ -11604,7 +11604,7 @@
         <p:spPr>
           <a:xfrm>
             <a:off x="6448320" y="1495440"/>
-            <a:ext cx="5257080" cy="266040"/>
+            <a:ext cx="5256720" cy="265680"/>
           </a:xfrm>
           <a:prstGeom prst="rect">
             <a:avLst/>
@@ -11656,7 +11656,7 @@
         <p:spPr>
           <a:xfrm>
             <a:off x="6448320" y="1876320"/>
-            <a:ext cx="5238000" cy="227880"/>
+            <a:ext cx="5237640" cy="227520"/>
           </a:xfrm>
           <a:prstGeom prst="rect">
             <a:avLst/>
@@ -11718,7 +11718,7 @@
         <p:spPr>
           <a:xfrm>
             <a:off x="6448320" y="2181240"/>
-            <a:ext cx="5238000" cy="227880"/>
+            <a:ext cx="5237640" cy="227520"/>
           </a:xfrm>
           <a:prstGeom prst="rect">
             <a:avLst/>
@@ -11780,7 +11780,7 @@
         <p:spPr>
           <a:xfrm>
             <a:off x="6448320" y="2486160"/>
-            <a:ext cx="5238000" cy="227880"/>
+            <a:ext cx="5237640" cy="227520"/>
           </a:xfrm>
           <a:prstGeom prst="rect">
             <a:avLst/>
@@ -11832,7 +11832,7 @@
         <p:spPr>
           <a:xfrm>
             <a:off x="6267600" y="3067200"/>
-            <a:ext cx="5542920" cy="2133000"/>
+            <a:ext cx="5542560" cy="2132640"/>
           </a:xfrm>
           <a:custGeom>
             <a:avLst/>
@@ -11883,7 +11883,7 @@
         <p:spPr>
           <a:xfrm>
             <a:off x="6267600" y="3067200"/>
-            <a:ext cx="37440" cy="2133000"/>
+            <a:ext cx="37080" cy="2132640"/>
           </a:xfrm>
           <a:custGeom>
             <a:avLst/>
@@ -11934,7 +11934,7 @@
         <p:spPr>
           <a:xfrm>
             <a:off x="6477120" y="3257640"/>
-            <a:ext cx="5238000" cy="266040"/>
+            <a:ext cx="5237640" cy="265680"/>
           </a:xfrm>
           <a:prstGeom prst="rect">
             <a:avLst/>
@@ -11986,7 +11986,7 @@
         <p:spPr>
           <a:xfrm>
             <a:off x="6496200" y="3672000"/>
-            <a:ext cx="151560" cy="151560"/>
+            <a:ext cx="151200" cy="151200"/>
           </a:xfrm>
           <a:custGeom>
             <a:avLst/>
@@ -12110,7 +12110,7 @@
         <p:spPr>
           <a:xfrm>
             <a:off x="6724800" y="3638520"/>
-            <a:ext cx="4971240" cy="456480"/>
+            <a:ext cx="4970880" cy="456120"/>
           </a:xfrm>
           <a:prstGeom prst="rect">
             <a:avLst/>
@@ -12172,7 +12172,7 @@
         <p:spPr>
           <a:xfrm>
             <a:off x="6496200" y="4205160"/>
-            <a:ext cx="151560" cy="151560"/>
+            <a:ext cx="151200" cy="151200"/>
           </a:xfrm>
           <a:custGeom>
             <a:avLst/>
@@ -12295,7 +12295,7 @@
         <p:spPr>
           <a:xfrm>
             <a:off x="6724800" y="4172040"/>
-            <a:ext cx="4971240" cy="227880"/>
+            <a:ext cx="4970880" cy="227520"/>
           </a:xfrm>
           <a:prstGeom prst="rect">
             <a:avLst/>
@@ -12357,7 +12357,7 @@
         <p:spPr>
           <a:xfrm>
             <a:off x="6515280" y="4510080"/>
-            <a:ext cx="113760" cy="151560"/>
+            <a:ext cx="113400" cy="151200"/>
           </a:xfrm>
           <a:custGeom>
             <a:avLst/>
@@ -12598,7 +12598,7 @@
         <p:spPr>
           <a:xfrm>
             <a:off x="6724800" y="4476600"/>
-            <a:ext cx="4971240" cy="227880"/>
+            <a:ext cx="4970880" cy="227520"/>
           </a:xfrm>
           <a:prstGeom prst="rect">
             <a:avLst/>
@@ -12660,7 +12660,7 @@
         <p:spPr>
           <a:xfrm>
             <a:off x="6486480" y="4815000"/>
-            <a:ext cx="170640" cy="151560"/>
+            <a:ext cx="170280" cy="151200"/>
           </a:xfrm>
           <a:custGeom>
             <a:avLst/>
@@ -12896,7 +12896,7 @@
         <p:spPr>
           <a:xfrm>
             <a:off x="6724800" y="4781520"/>
-            <a:ext cx="4971240" cy="227880"/>
+            <a:ext cx="4970880" cy="227520"/>
           </a:xfrm>
           <a:prstGeom prst="rect">
             <a:avLst/>
@@ -12995,7 +12995,7 @@
         <p:spPr>
           <a:xfrm>
             <a:off x="358560" y="358560"/>
-            <a:ext cx="11545920" cy="214560"/>
+            <a:ext cx="11545560" cy="214200"/>
           </a:xfrm>
           <a:prstGeom prst="rect">
             <a:avLst/>
@@ -13023,7 +13023,7 @@
               <a:buNone/>
             </a:pPr>
             <a:r>
-              <a:rPr b="1" lang="en-US" sz="1130" spc="52" strike="noStrike">
+              <a:rPr b="1" lang="en-US" sz="1130" spc="49" strike="noStrike">
                 <a:solidFill>
                   <a:srgbClr val="0984e3"/>
                 </a:solidFill>
@@ -13047,7 +13047,7 @@
         <p:spPr>
           <a:xfrm>
             <a:off x="358560" y="645480"/>
-            <a:ext cx="11689200" cy="429480"/>
+            <a:ext cx="11688840" cy="429120"/>
           </a:xfrm>
           <a:prstGeom prst="rect">
             <a:avLst/>
@@ -13099,7 +13099,7 @@
         <p:spPr>
           <a:xfrm>
             <a:off x="358560" y="1290960"/>
-            <a:ext cx="5700960" cy="286200"/>
+            <a:ext cx="5700600" cy="285840"/>
           </a:xfrm>
           <a:prstGeom prst="rect">
             <a:avLst/>
@@ -13151,7 +13151,7 @@
         <p:spPr>
           <a:xfrm>
             <a:off x="358560" y="1725840"/>
-            <a:ext cx="5473800" cy="440640"/>
+            <a:ext cx="5473440" cy="440280"/>
           </a:xfrm>
           <a:prstGeom prst="rect">
             <a:avLst/>
@@ -13203,7 +13203,7 @@
         <p:spPr>
           <a:xfrm>
             <a:off x="358560" y="2317320"/>
-            <a:ext cx="5664960" cy="465480"/>
+            <a:ext cx="5664600" cy="465120"/>
           </a:xfrm>
           <a:prstGeom prst="rect">
             <a:avLst/>
@@ -13255,7 +13255,7 @@
         <p:spPr>
           <a:xfrm>
             <a:off x="363240" y="2931480"/>
-            <a:ext cx="5584320" cy="1873080"/>
+            <a:ext cx="5583960" cy="1872720"/>
           </a:xfrm>
           <a:custGeom>
             <a:avLst/>
@@ -13309,7 +13309,7 @@
         <p:spPr>
           <a:xfrm>
             <a:off x="470520" y="3079440"/>
-            <a:ext cx="5369040" cy="250200"/>
+            <a:ext cx="5368680" cy="249840"/>
           </a:xfrm>
           <a:prstGeom prst="rect">
             <a:avLst/>
@@ -13837,7 +13837,7 @@
         <p:spPr>
           <a:xfrm>
             <a:off x="479520" y="4478040"/>
-            <a:ext cx="5351040" cy="178560"/>
+            <a:ext cx="5350680" cy="178200"/>
           </a:xfrm>
           <a:prstGeom prst="rect">
             <a:avLst/>
@@ -13889,7 +13889,7 @@
         <p:spPr>
           <a:xfrm>
             <a:off x="376560" y="4952880"/>
-            <a:ext cx="5575320" cy="752400"/>
+            <a:ext cx="5574960" cy="752040"/>
           </a:xfrm>
           <a:custGeom>
             <a:avLst/>
@@ -13940,7 +13940,7 @@
         <p:spPr>
           <a:xfrm>
             <a:off x="376560" y="4952880"/>
-            <a:ext cx="35280" cy="752400"/>
+            <a:ext cx="34920" cy="752040"/>
           </a:xfrm>
           <a:custGeom>
             <a:avLst/>
@@ -13991,7 +13991,7 @@
         <p:spPr>
           <a:xfrm>
             <a:off x="537840" y="5096520"/>
-            <a:ext cx="5342400" cy="465480"/>
+            <a:ext cx="5342040" cy="465120"/>
           </a:xfrm>
           <a:prstGeom prst="rect">
             <a:avLst/>
@@ -14053,7 +14053,7 @@
         <p:spPr>
           <a:xfrm>
             <a:off x="6239520" y="1290960"/>
-            <a:ext cx="5700960" cy="286200"/>
+            <a:ext cx="5700600" cy="285840"/>
           </a:xfrm>
           <a:prstGeom prst="rect">
             <a:avLst/>
@@ -14105,7 +14105,7 @@
         <p:spPr>
           <a:xfrm>
             <a:off x="6239520" y="1685520"/>
-            <a:ext cx="5673960" cy="528120"/>
+            <a:ext cx="5673600" cy="527760"/>
           </a:xfrm>
           <a:prstGeom prst="rect">
             <a:avLst/>
@@ -14167,7 +14167,7 @@
         <p:spPr>
           <a:xfrm>
             <a:off x="6239520" y="2317320"/>
-            <a:ext cx="5664960" cy="698400"/>
+            <a:ext cx="5664600" cy="698040"/>
           </a:xfrm>
           <a:prstGeom prst="rect">
             <a:avLst/>
@@ -14219,7 +14219,7 @@
         <p:spPr>
           <a:xfrm>
             <a:off x="6243840" y="3164400"/>
-            <a:ext cx="5584320" cy="1873080"/>
+            <a:ext cx="5583960" cy="1872720"/>
           </a:xfrm>
           <a:custGeom>
             <a:avLst/>
@@ -14273,7 +14273,7 @@
         <p:spPr>
           <a:xfrm>
             <a:off x="6351480" y="3312360"/>
-            <a:ext cx="5369040" cy="250200"/>
+            <a:ext cx="5368680" cy="249840"/>
           </a:xfrm>
           <a:prstGeom prst="rect">
             <a:avLst/>
@@ -14799,7 +14799,7 @@
         <p:spPr>
           <a:xfrm>
             <a:off x="6360480" y="4710960"/>
-            <a:ext cx="5351040" cy="178560"/>
+            <a:ext cx="5350680" cy="178200"/>
           </a:xfrm>
           <a:prstGeom prst="rect">
             <a:avLst/>
@@ -14851,7 +14851,7 @@
         <p:spPr>
           <a:xfrm>
             <a:off x="6239520" y="5186160"/>
-            <a:ext cx="5593320" cy="1308240"/>
+            <a:ext cx="5592960" cy="1307880"/>
           </a:xfrm>
           <a:custGeom>
             <a:avLst/>
@@ -14902,7 +14902,7 @@
         <p:spPr>
           <a:xfrm>
             <a:off x="6382800" y="5329440"/>
-            <a:ext cx="5387040" cy="250200"/>
+            <a:ext cx="5386680" cy="249840"/>
           </a:xfrm>
           <a:prstGeom prst="rect">
             <a:avLst/>
@@ -14954,7 +14954,7 @@
         <p:spPr>
           <a:xfrm>
             <a:off x="6382800" y="5652360"/>
-            <a:ext cx="5378040" cy="698400"/>
+            <a:ext cx="5377680" cy="698040"/>
           </a:xfrm>
           <a:prstGeom prst="rect">
             <a:avLst/>
@@ -15043,7 +15043,7 @@
         <p:spPr>
           <a:xfrm>
             <a:off x="609480" y="1781280"/>
-            <a:ext cx="12191400" cy="1218600"/>
+            <a:ext cx="12191040" cy="1218240"/>
           </a:xfrm>
           <a:prstGeom prst="rect">
             <a:avLst/>
@@ -15097,7 +15097,7 @@
         <p:spPr>
           <a:xfrm>
             <a:off x="609480" y="3152880"/>
-            <a:ext cx="11867400" cy="1142280"/>
+            <a:ext cx="11867040" cy="1141920"/>
           </a:xfrm>
           <a:prstGeom prst="rect">
             <a:avLst/>
@@ -15170,7 +15170,7 @@
         <p:spPr>
           <a:xfrm>
             <a:off x="609480" y="4524480"/>
-            <a:ext cx="1218600" cy="18360"/>
+            <a:ext cx="1218240" cy="18000"/>
           </a:xfrm>
           <a:custGeom>
             <a:avLst/>
@@ -15221,7 +15221,7 @@
         <p:spPr>
           <a:xfrm>
             <a:off x="609480" y="4772160"/>
-            <a:ext cx="11696040" cy="304200"/>
+            <a:ext cx="11695680" cy="303840"/>
           </a:xfrm>
           <a:prstGeom prst="rect">
             <a:avLst/>
@@ -15310,7 +15310,7 @@
         <p:spPr>
           <a:xfrm>
             <a:off x="380880" y="380880"/>
-            <a:ext cx="11657880" cy="456480"/>
+            <a:ext cx="11657520" cy="456120"/>
           </a:xfrm>
           <a:prstGeom prst="rect">
             <a:avLst/>
@@ -15362,7 +15362,7 @@
         <p:spPr>
           <a:xfrm>
             <a:off x="380880" y="952560"/>
-            <a:ext cx="761400" cy="18360"/>
+            <a:ext cx="761040" cy="18000"/>
           </a:xfrm>
           <a:custGeom>
             <a:avLst/>
@@ -15413,7 +15413,7 @@
         <p:spPr>
           <a:xfrm>
             <a:off x="380880" y="1428840"/>
-            <a:ext cx="751680" cy="570960"/>
+            <a:ext cx="751320" cy="570600"/>
           </a:xfrm>
           <a:prstGeom prst="rect">
             <a:avLst/>
@@ -15467,7 +15467,7 @@
         <p:spPr>
           <a:xfrm>
             <a:off x="1034280" y="1504800"/>
-            <a:ext cx="4190400" cy="304200"/>
+            <a:ext cx="4190040" cy="303840"/>
           </a:xfrm>
           <a:prstGeom prst="rect">
             <a:avLst/>
@@ -15519,7 +15519,7 @@
         <p:spPr>
           <a:xfrm>
             <a:off x="1034280" y="1886040"/>
-            <a:ext cx="4161600" cy="275400"/>
+            <a:ext cx="4161240" cy="275040"/>
           </a:xfrm>
           <a:prstGeom prst="rect">
             <a:avLst/>
@@ -15571,7 +15571,7 @@
         <p:spPr>
           <a:xfrm>
             <a:off x="6400800" y="1428840"/>
-            <a:ext cx="856440" cy="570960"/>
+            <a:ext cx="856080" cy="570600"/>
           </a:xfrm>
           <a:prstGeom prst="rect">
             <a:avLst/>
@@ -15625,7 +15625,7 @@
         <p:spPr>
           <a:xfrm>
             <a:off x="7160040" y="1504800"/>
-            <a:ext cx="4761720" cy="304200"/>
+            <a:ext cx="4761360" cy="303840"/>
           </a:xfrm>
           <a:prstGeom prst="rect">
             <a:avLst/>
@@ -15677,7 +15677,7 @@
         <p:spPr>
           <a:xfrm>
             <a:off x="7160040" y="1886040"/>
-            <a:ext cx="4733280" cy="561240"/>
+            <a:ext cx="4732920" cy="560880"/>
           </a:xfrm>
           <a:prstGeom prst="rect">
             <a:avLst/>
@@ -15729,7 +15729,7 @@
         <p:spPr>
           <a:xfrm>
             <a:off x="380880" y="2824200"/>
-            <a:ext cx="856440" cy="570960"/>
+            <a:ext cx="856080" cy="570600"/>
           </a:xfrm>
           <a:prstGeom prst="rect">
             <a:avLst/>
@@ -15783,7 +15783,7 @@
         <p:spPr>
           <a:xfrm>
             <a:off x="1143000" y="2900520"/>
-            <a:ext cx="3971160" cy="304200"/>
+            <a:ext cx="3970800" cy="303840"/>
           </a:xfrm>
           <a:prstGeom prst="rect">
             <a:avLst/>
@@ -15835,7 +15835,7 @@
         <p:spPr>
           <a:xfrm>
             <a:off x="1143000" y="3281400"/>
-            <a:ext cx="3942720" cy="275400"/>
+            <a:ext cx="3942360" cy="275040"/>
           </a:xfrm>
           <a:prstGeom prst="rect">
             <a:avLst/>
@@ -15887,7 +15887,7 @@
         <p:spPr>
           <a:xfrm>
             <a:off x="6400800" y="2824200"/>
-            <a:ext cx="885240" cy="570960"/>
+            <a:ext cx="884880" cy="570600"/>
           </a:xfrm>
           <a:prstGeom prst="rect">
             <a:avLst/>
@@ -15941,7 +15941,7 @@
         <p:spPr>
           <a:xfrm>
             <a:off x="7188480" y="2900520"/>
-            <a:ext cx="2475720" cy="304200"/>
+            <a:ext cx="2475360" cy="303840"/>
           </a:xfrm>
           <a:prstGeom prst="rect">
             <a:avLst/>
@@ -15993,7 +15993,7 @@
         <p:spPr>
           <a:xfrm>
             <a:off x="7188480" y="3281400"/>
-            <a:ext cx="2447280" cy="275400"/>
+            <a:ext cx="2446920" cy="275040"/>
           </a:xfrm>
           <a:prstGeom prst="rect">
             <a:avLst/>
@@ -16045,7 +16045,7 @@
         <p:spPr>
           <a:xfrm>
             <a:off x="380880" y="3940920"/>
-            <a:ext cx="847080" cy="570960"/>
+            <a:ext cx="846720" cy="570600"/>
           </a:xfrm>
           <a:prstGeom prst="rect">
             <a:avLst/>
@@ -16099,7 +16099,7 @@
         <p:spPr>
           <a:xfrm>
             <a:off x="1137240" y="4017240"/>
-            <a:ext cx="2866320" cy="304200"/>
+            <a:ext cx="2865960" cy="303840"/>
           </a:xfrm>
           <a:prstGeom prst="rect">
             <a:avLst/>
@@ -16151,7 +16151,7 @@
         <p:spPr>
           <a:xfrm>
             <a:off x="1137240" y="4398120"/>
-            <a:ext cx="2837880" cy="275400"/>
+            <a:ext cx="2837520" cy="275040"/>
           </a:xfrm>
           <a:prstGeom prst="rect">
             <a:avLst/>
@@ -16203,7 +16203,7 @@
         <p:spPr>
           <a:xfrm>
             <a:off x="6400800" y="3940920"/>
-            <a:ext cx="866160" cy="570960"/>
+            <a:ext cx="865800" cy="570600"/>
           </a:xfrm>
           <a:prstGeom prst="rect">
             <a:avLst/>
@@ -16257,7 +16257,7 @@
         <p:spPr>
           <a:xfrm>
             <a:off x="7171560" y="4017240"/>
-            <a:ext cx="3075840" cy="304200"/>
+            <a:ext cx="3075480" cy="303840"/>
           </a:xfrm>
           <a:prstGeom prst="rect">
             <a:avLst/>
@@ -16309,7 +16309,7 @@
         <p:spPr>
           <a:xfrm>
             <a:off x="7171560" y="4398120"/>
-            <a:ext cx="3047400" cy="275400"/>
+            <a:ext cx="3047040" cy="275040"/>
           </a:xfrm>
           <a:prstGeom prst="rect">
             <a:avLst/>
@@ -16398,7 +16398,7 @@
         <p:spPr>
           <a:xfrm>
             <a:off x="609480" y="1781280"/>
-            <a:ext cx="12191400" cy="1218600"/>
+            <a:ext cx="12191040" cy="1218240"/>
           </a:xfrm>
           <a:prstGeom prst="rect">
             <a:avLst/>
@@ -16452,7 +16452,7 @@
         <p:spPr>
           <a:xfrm>
             <a:off x="609480" y="3152880"/>
-            <a:ext cx="11867400" cy="1142280"/>
+            <a:ext cx="11867040" cy="1141920"/>
           </a:xfrm>
           <a:prstGeom prst="rect">
             <a:avLst/>
@@ -16487,40 +16487,30 @@
                 <a:latin typeface="Oranienbaum"/>
                 <a:ea typeface="Oranienbaum"/>
               </a:rPr>
-              <a:t>Introduction</a:t>
-            </a:r>
-            <a:r>
-              <a:rPr b="1" lang="en-US" sz="4500" spc="-1" strike="noStrike">
+              <a:t>Introduction to</a:t>
+            </a:r>
+            <a:endParaRPr b="0" lang="en-HK" sz="3600" spc="-1" strike="noStrike">
+              <a:latin typeface="Arial"/>
+            </a:endParaRPr>
+          </a:p>
+          <a:p>
+            <a:pPr>
+              <a:lnSpc>
+                <a:spcPct val="80000"/>
+              </a:lnSpc>
+              <a:buNone/>
+            </a:pPr>
+            <a:r>
+              <a:rPr b="1" lang="en-US" sz="3600" spc="-1" strike="noStrike">
                 <a:solidFill>
                   <a:srgbClr val="2d3436"/>
                 </a:solidFill>
                 <a:latin typeface="Oranienbaum"/>
                 <a:ea typeface="Oranienbaum"/>
               </a:rPr>
-              <a:t> to</a:t>
-            </a:r>
-            <a:endParaRPr b="0" lang="en-HK" sz="4500" spc="-1" strike="noStrike">
-              <a:latin typeface="Arial"/>
-            </a:endParaRPr>
-          </a:p>
-          <a:p>
-            <a:pPr>
-              <a:lnSpc>
-                <a:spcPct val="80000"/>
-              </a:lnSpc>
-              <a:buNone/>
-            </a:pPr>
-            <a:r>
-              <a:rPr b="1" lang="en-US" sz="4500" spc="-1" strike="noStrike">
-                <a:solidFill>
-                  <a:srgbClr val="2d3436"/>
-                </a:solidFill>
-                <a:latin typeface="Oranienbaum"/>
-                <a:ea typeface="Oranienbaum"/>
-              </a:rPr>
               <a:t>Game Theory</a:t>
             </a:r>
-            <a:endParaRPr b="0" lang="en-HK" sz="4500" spc="-1" strike="noStrike">
+            <a:endParaRPr b="0" lang="en-HK" sz="3600" spc="-1" strike="noStrike">
               <a:latin typeface="Arial"/>
             </a:endParaRPr>
           </a:p>
@@ -16535,7 +16525,7 @@
         <p:spPr>
           <a:xfrm>
             <a:off x="609480" y="4524480"/>
-            <a:ext cx="1218600" cy="18360"/>
+            <a:ext cx="1218240" cy="18000"/>
           </a:xfrm>
           <a:custGeom>
             <a:avLst/>
@@ -16586,7 +16576,7 @@
         <p:spPr>
           <a:xfrm>
             <a:off x="609480" y="4772160"/>
-            <a:ext cx="11696040" cy="304200"/>
+            <a:ext cx="11695680" cy="303840"/>
           </a:xfrm>
           <a:prstGeom prst="rect">
             <a:avLst/>
@@ -16675,7 +16665,7 @@
         <p:spPr>
           <a:xfrm>
             <a:off x="380880" y="380880"/>
-            <a:ext cx="11505600" cy="227880"/>
+            <a:ext cx="11505240" cy="227520"/>
           </a:xfrm>
           <a:prstGeom prst="rect">
             <a:avLst/>
@@ -16703,7 +16693,7 @@
               <a:buNone/>
             </a:pPr>
             <a:r>
-              <a:rPr b="1" lang="en-US" sz="1200" spc="55" strike="noStrike">
+              <a:rPr b="1" lang="en-US" sz="1200" spc="52" strike="noStrike">
                 <a:solidFill>
                   <a:srgbClr val="0984e3"/>
                 </a:solidFill>
@@ -16727,7 +16717,7 @@
         <p:spPr>
           <a:xfrm>
             <a:off x="380880" y="685800"/>
-            <a:ext cx="11657880" cy="456480"/>
+            <a:ext cx="11657520" cy="456120"/>
           </a:xfrm>
           <a:prstGeom prst="rect">
             <a:avLst/>
@@ -16779,7 +16769,7 @@
         <p:spPr>
           <a:xfrm>
             <a:off x="380880" y="1371600"/>
-            <a:ext cx="6828840" cy="1237680"/>
+            <a:ext cx="6828480" cy="1237320"/>
           </a:xfrm>
           <a:prstGeom prst="rect">
             <a:avLst/>
@@ -16807,9 +16797,9 @@
               <a:buNone/>
             </a:pPr>
             <a:r>
-              <a:rPr b="1" lang="en-US" sz="1500" spc="-1" strike="noStrike">
+              <a:rPr b="1" i="1" lang="en-US" sz="1500" spc="-1" strike="noStrike">
                 <a:solidFill>
-                  <a:srgbClr val="00008b"/>
+                  <a:srgbClr val="2a6099"/>
                 </a:solidFill>
                 <a:latin typeface="Quattrocento Sans"/>
                 <a:ea typeface="Quattrocento Sans"/>
@@ -16817,18 +16807,18 @@
               <a:t>Game theory is a mathematical framework for analyzing strategic interactions among rational decision-makers.</a:t>
             </a:r>
             <a:r>
-              <a:rPr b="0" lang="en-US" sz="1500" spc="-1" strike="noStrike">
+              <a:rPr b="0" i="1" lang="en-US" sz="1500" spc="-1" strike="noStrike">
                 <a:solidFill>
-                  <a:srgbClr val="00008b"/>
+                  <a:srgbClr val="2a6099"/>
                 </a:solidFill>
                 <a:latin typeface="Quattrocento Sans"/>
                 <a:ea typeface="Quattrocento Sans"/>
               </a:rPr>
               <a:t> It provides a structured approach to understanding how individuals or groups make decisions in situations where the outcome depends on the choices of multiple participants.</a:t>
             </a:r>
-            <a:endParaRPr b="0" lang="en-HK" sz="1500" spc="-1" strike="noStrike">
+            <a:endParaRPr b="0" i="1" lang="en-HK" sz="1500" spc="-1" strike="noStrike">
               <a:solidFill>
-                <a:srgbClr val="00008b"/>
+                <a:srgbClr val="2a6099"/>
               </a:solidFill>
               <a:latin typeface="Arial"/>
             </a:endParaRPr>
@@ -16844,7 +16834,7 @@
         <p:spPr>
           <a:xfrm>
             <a:off x="380880" y="2838600"/>
-            <a:ext cx="6819120" cy="1113840"/>
+            <a:ext cx="6818760" cy="1113480"/>
           </a:xfrm>
           <a:prstGeom prst="rect">
             <a:avLst/>
@@ -16896,7 +16886,7 @@
         <p:spPr>
           <a:xfrm>
             <a:off x="399960" y="4986360"/>
-            <a:ext cx="6714360" cy="1361520"/>
+            <a:ext cx="6714000" cy="1361160"/>
           </a:xfrm>
           <a:custGeom>
             <a:avLst/>
@@ -16947,7 +16937,7 @@
         <p:spPr>
           <a:xfrm>
             <a:off x="399960" y="4986360"/>
-            <a:ext cx="37440" cy="1361520"/>
+            <a:ext cx="37080" cy="1361160"/>
           </a:xfrm>
           <a:custGeom>
             <a:avLst/>
@@ -16998,7 +16988,7 @@
         <p:spPr>
           <a:xfrm>
             <a:off x="647640" y="5214960"/>
-            <a:ext cx="6323760" cy="561240"/>
+            <a:ext cx="6323400" cy="560880"/>
           </a:xfrm>
           <a:prstGeom prst="rect">
             <a:avLst/>
@@ -17050,7 +17040,7 @@
         <p:spPr>
           <a:xfrm>
             <a:off x="647640" y="5886360"/>
-            <a:ext cx="6314400" cy="227880"/>
+            <a:ext cx="6314040" cy="227520"/>
           </a:xfrm>
           <a:prstGeom prst="rect">
             <a:avLst/>
@@ -17112,7 +17102,7 @@
         <p:spPr>
           <a:xfrm>
             <a:off x="7426440" y="1376280"/>
-            <a:ext cx="4380840" cy="1494720"/>
+            <a:ext cx="4380480" cy="1494360"/>
           </a:xfrm>
           <a:custGeom>
             <a:avLst/>
@@ -17166,7 +17156,7 @@
         <p:spPr>
           <a:xfrm>
             <a:off x="7660080" y="1609560"/>
-            <a:ext cx="380160" cy="380160"/>
+            <a:ext cx="379800" cy="379800"/>
           </a:xfrm>
           <a:custGeom>
             <a:avLst/>
@@ -17217,7 +17207,7 @@
         <p:spPr>
           <a:xfrm>
             <a:off x="7745760" y="1714680"/>
-            <a:ext cx="213480" cy="170640"/>
+            <a:ext cx="213120" cy="170280"/>
           </a:xfrm>
           <a:custGeom>
             <a:avLst/>
@@ -17433,7 +17423,7 @@
         <p:spPr>
           <a:xfrm>
             <a:off x="8155440" y="1666800"/>
-            <a:ext cx="637560" cy="266040"/>
+            <a:ext cx="637200" cy="265680"/>
           </a:xfrm>
           <a:prstGeom prst="rect">
             <a:avLst/>
@@ -17485,7 +17475,7 @@
         <p:spPr>
           <a:xfrm>
             <a:off x="7660080" y="2143080"/>
-            <a:ext cx="3990240" cy="494640"/>
+            <a:ext cx="3989880" cy="494280"/>
           </a:xfrm>
           <a:prstGeom prst="rect">
             <a:avLst/>
@@ -17537,7 +17527,7 @@
         <p:spPr>
           <a:xfrm>
             <a:off x="7426440" y="3110040"/>
-            <a:ext cx="4380840" cy="1494720"/>
+            <a:ext cx="4380480" cy="1494360"/>
           </a:xfrm>
           <a:custGeom>
             <a:avLst/>
@@ -17591,7 +17581,7 @@
         <p:spPr>
           <a:xfrm>
             <a:off x="7660080" y="3343320"/>
-            <a:ext cx="380160" cy="380160"/>
+            <a:ext cx="379800" cy="379800"/>
           </a:xfrm>
           <a:custGeom>
             <a:avLst/>
@@ -17642,7 +17632,7 @@
         <p:spPr>
           <a:xfrm>
             <a:off x="7767000" y="3448080"/>
-            <a:ext cx="170640" cy="170640"/>
+            <a:ext cx="170280" cy="170280"/>
           </a:xfrm>
           <a:custGeom>
             <a:avLst/>
@@ -17918,7 +17908,7 @@
         <p:spPr>
           <a:xfrm>
             <a:off x="8155440" y="3400560"/>
-            <a:ext cx="866160" cy="266040"/>
+            <a:ext cx="865800" cy="265680"/>
           </a:xfrm>
           <a:prstGeom prst="rect">
             <a:avLst/>
@@ -17970,7 +17960,7 @@
         <p:spPr>
           <a:xfrm>
             <a:off x="7660080" y="3876840"/>
-            <a:ext cx="3990240" cy="494640"/>
+            <a:ext cx="3989880" cy="494280"/>
           </a:xfrm>
           <a:prstGeom prst="rect">
             <a:avLst/>
@@ -18022,7 +18012,7 @@
         <p:spPr>
           <a:xfrm>
             <a:off x="7426440" y="4843440"/>
-            <a:ext cx="4380840" cy="1494720"/>
+            <a:ext cx="4380480" cy="1494360"/>
           </a:xfrm>
           <a:custGeom>
             <a:avLst/>
@@ -18076,7 +18066,7 @@
         <p:spPr>
           <a:xfrm>
             <a:off x="7660080" y="5076720"/>
-            <a:ext cx="380160" cy="380160"/>
+            <a:ext cx="379800" cy="379800"/>
           </a:xfrm>
           <a:custGeom>
             <a:avLst/>
@@ -18127,7 +18117,7 @@
         <p:spPr>
           <a:xfrm>
             <a:off x="7767000" y="5181480"/>
-            <a:ext cx="170640" cy="170640"/>
+            <a:ext cx="170280" cy="170280"/>
           </a:xfrm>
           <a:custGeom>
             <a:avLst/>
@@ -18304,7 +18294,7 @@
         <p:spPr>
           <a:xfrm>
             <a:off x="8155440" y="5133960"/>
-            <a:ext cx="656640" cy="266040"/>
+            <a:ext cx="656280" cy="265680"/>
           </a:xfrm>
           <a:prstGeom prst="rect">
             <a:avLst/>
@@ -18356,7 +18346,7 @@
         <p:spPr>
           <a:xfrm>
             <a:off x="7660080" y="5610240"/>
-            <a:ext cx="3990240" cy="494640"/>
+            <a:ext cx="3989880" cy="494280"/>
           </a:xfrm>
           <a:prstGeom prst="rect">
             <a:avLst/>
@@ -18445,7 +18435,7 @@
         <p:spPr>
           <a:xfrm>
             <a:off x="609480" y="1781280"/>
-            <a:ext cx="12191400" cy="1218600"/>
+            <a:ext cx="12191040" cy="1218240"/>
           </a:xfrm>
           <a:prstGeom prst="rect">
             <a:avLst/>
@@ -18499,7 +18489,7 @@
         <p:spPr>
           <a:xfrm>
             <a:off x="609480" y="3152880"/>
-            <a:ext cx="11867400" cy="1142280"/>
+            <a:ext cx="11867040" cy="1141920"/>
           </a:xfrm>
           <a:prstGeom prst="rect">
             <a:avLst/>
@@ -18572,7 +18562,7 @@
         <p:spPr>
           <a:xfrm>
             <a:off x="609480" y="4524480"/>
-            <a:ext cx="1218600" cy="18360"/>
+            <a:ext cx="1218240" cy="18000"/>
           </a:xfrm>
           <a:custGeom>
             <a:avLst/>
@@ -18623,7 +18613,7 @@
         <p:spPr>
           <a:xfrm>
             <a:off x="609480" y="4772160"/>
-            <a:ext cx="11696040" cy="304200"/>
+            <a:ext cx="11695680" cy="303840"/>
           </a:xfrm>
           <a:prstGeom prst="rect">
             <a:avLst/>
@@ -18669,44 +18659,44 @@
       <p:sp>
         <p:nvSpPr>
           <p:cNvPr id="99" name=""/>
-          <p:cNvSpPr txBox="1"/>
+          <p:cNvSpPr/>
           <p:nvPr/>
         </p:nvSpPr>
         <p:spPr>
           <a:xfrm>
             <a:off x="2133000" y="5394600"/>
-            <a:ext cx="16458480" cy="346320"/>
-          </a:xfrm>
-          <a:prstGeom prst="rect">
-            <a:avLst/>
-          </a:prstGeom>
-          <a:noFill/>
-          <a:ln w="0">
-            <a:noFill/>
-          </a:ln>
-        </p:spPr>
+            <a:ext cx="16458120" cy="345960"/>
+          </a:xfrm>
+          <a:prstGeom prst="rect">
+            <a:avLst/>
+          </a:prstGeom>
+          <a:noFill/>
+          <a:ln w="0">
+            <a:noFill/>
+          </a:ln>
+        </p:spPr>
+        <p:style>
+          <a:lnRef idx="0"/>
+          <a:fillRef idx="0"/>
+          <a:effectRef idx="0"/>
+          <a:fontRef idx="minor"/>
+        </p:style>
         <p:txBody>
           <a:bodyPr lIns="90000" rIns="90000" tIns="45000" bIns="45000" anchor="t">
             <a:noAutofit/>
           </a:bodyPr>
           <a:p>
+            <a:pPr>
+              <a:lnSpc>
+                <a:spcPct val="100000"/>
+              </a:lnSpc>
+              <a:buNone/>
+            </a:pPr>
             <a:r>
               <a:rPr b="0" lang="en-HK" sz="1800" spc="-1" strike="noStrike">
                 <a:latin typeface="Arial"/>
               </a:rPr>
-              <a:t>Key concept: Nash Equilibrium occurs when no player can </a:t>
-            </a:r>
-            <a:r>
-              <a:rPr b="0" lang="en-HK" sz="1800" spc="-1" strike="noStrike">
-                <a:latin typeface="Arial"/>
-              </a:rPr>
-              <a:t>improve their payoff by unilaterally changing their strategy, given </a:t>
-            </a:r>
-            <a:r>
-              <a:rPr b="0" lang="en-HK" sz="1800" spc="-1" strike="noStrike">
-                <a:latin typeface="Arial"/>
-              </a:rPr>
-              <a:t>other players’ strategies remain fixed.</a:t>
+              <a:t>Key concept: Nash Equilibrium occurs when no player can improve their payoff by unilaterally changing their strategy, given other players’ strategies remain fixed.</a:t>
             </a:r>
             <a:endParaRPr b="0" lang="en-HK" sz="1800" spc="-1" strike="noStrike">
               <a:latin typeface="Arial"/>
@@ -18733,7 +18723,7 @@
     <p:bg>
       <p:bgPr>
         <a:solidFill>
-          <a:srgbClr val="ffffff"/>
+          <a:srgbClr val="999999"/>
         </a:solidFill>
       </p:bgPr>
     </p:bg>
@@ -18760,7 +18750,7 @@
         <p:spPr>
           <a:xfrm>
             <a:off x="324360" y="324360"/>
-            <a:ext cx="11607480" cy="193680"/>
+            <a:ext cx="11607120" cy="193320"/>
           </a:xfrm>
           <a:prstGeom prst="rect">
             <a:avLst/>
@@ -18788,7 +18778,7 @@
               <a:buNone/>
             </a:pPr>
             <a:r>
-              <a:rPr b="1" lang="en-US" sz="1020" spc="46" strike="noStrike">
+              <a:rPr b="1" lang="en-US" sz="1020" spc="43" strike="noStrike">
                 <a:solidFill>
                   <a:srgbClr val="0984e3"/>
                 </a:solidFill>
@@ -18812,7 +18802,7 @@
         <p:spPr>
           <a:xfrm>
             <a:off x="324360" y="583560"/>
-            <a:ext cx="11737440" cy="388440"/>
+            <a:ext cx="11737080" cy="388080"/>
           </a:xfrm>
           <a:prstGeom prst="rect">
             <a:avLst/>
@@ -18864,7 +18854,7 @@
         <p:spPr>
           <a:xfrm>
             <a:off x="6095880" y="1167480"/>
-            <a:ext cx="15480" cy="4976640"/>
+            <a:ext cx="15120" cy="4976280"/>
           </a:xfrm>
           <a:custGeom>
             <a:avLst/>
@@ -18915,7 +18905,7 @@
         <p:spPr>
           <a:xfrm>
             <a:off x="1638000" y="1171440"/>
-            <a:ext cx="3866040" cy="720720"/>
+            <a:ext cx="3865680" cy="720360"/>
           </a:xfrm>
           <a:custGeom>
             <a:avLst/>
@@ -18969,7 +18959,7 @@
         <p:spPr>
           <a:xfrm>
             <a:off x="1698840" y="1305000"/>
-            <a:ext cx="3671640" cy="226080"/>
+            <a:ext cx="3671280" cy="225720"/>
           </a:xfrm>
           <a:prstGeom prst="rect">
             <a:avLst/>
@@ -19021,7 +19011,7 @@
         <p:spPr>
           <a:xfrm>
             <a:off x="1706760" y="1564560"/>
-            <a:ext cx="3663360" cy="193680"/>
+            <a:ext cx="3663000" cy="193320"/>
           </a:xfrm>
           <a:prstGeom prst="rect">
             <a:avLst/>
@@ -19073,7 +19063,7 @@
         <p:spPr>
           <a:xfrm>
             <a:off x="6683760" y="2030760"/>
-            <a:ext cx="3290400" cy="720720"/>
+            <a:ext cx="3290040" cy="720360"/>
           </a:xfrm>
           <a:custGeom>
             <a:avLst/>
@@ -19127,7 +19117,7 @@
         <p:spPr>
           <a:xfrm>
             <a:off x="6817320" y="2164320"/>
-            <a:ext cx="3096000" cy="226080"/>
+            <a:ext cx="3095640" cy="225720"/>
           </a:xfrm>
           <a:prstGeom prst="rect">
             <a:avLst/>
@@ -19179,7 +19169,7 @@
         <p:spPr>
           <a:xfrm>
             <a:off x="6817320" y="2423880"/>
-            <a:ext cx="3087720" cy="193680"/>
+            <a:ext cx="3087360" cy="193320"/>
           </a:xfrm>
           <a:prstGeom prst="rect">
             <a:avLst/>
@@ -19231,7 +19221,7 @@
         <p:spPr>
           <a:xfrm>
             <a:off x="633600" y="2885760"/>
-            <a:ext cx="4879440" cy="712800"/>
+            <a:ext cx="4879080" cy="712440"/>
           </a:xfrm>
           <a:custGeom>
             <a:avLst/>
@@ -19282,7 +19272,7 @@
         <p:spPr>
           <a:xfrm>
             <a:off x="633600" y="2885760"/>
-            <a:ext cx="31680" cy="712800"/>
+            <a:ext cx="31320" cy="712440"/>
           </a:xfrm>
           <a:custGeom>
             <a:avLst/>
@@ -19333,7 +19323,7 @@
         <p:spPr>
           <a:xfrm>
             <a:off x="706680" y="3015720"/>
-            <a:ext cx="4676760" cy="226080"/>
+            <a:ext cx="4676400" cy="225720"/>
           </a:xfrm>
           <a:prstGeom prst="rect">
             <a:avLst/>
@@ -19385,7 +19375,7 @@
         <p:spPr>
           <a:xfrm>
             <a:off x="714960" y="3274920"/>
-            <a:ext cx="4668480" cy="193680"/>
+            <a:ext cx="4668120" cy="193320"/>
           </a:xfrm>
           <a:prstGeom prst="rect">
             <a:avLst/>
@@ -19447,7 +19437,7 @@
         <p:spPr>
           <a:xfrm>
             <a:off x="6696000" y="3728880"/>
-            <a:ext cx="5016960" cy="712800"/>
+            <a:ext cx="5016600" cy="712440"/>
           </a:xfrm>
           <a:custGeom>
             <a:avLst/>
@@ -19498,7 +19488,7 @@
         <p:spPr>
           <a:xfrm>
             <a:off x="6696000" y="3728880"/>
-            <a:ext cx="31680" cy="712800"/>
+            <a:ext cx="31320" cy="712440"/>
           </a:xfrm>
           <a:custGeom>
             <a:avLst/>
@@ -19549,7 +19539,7 @@
         <p:spPr>
           <a:xfrm>
             <a:off x="6841800" y="3858480"/>
-            <a:ext cx="4814640" cy="226080"/>
+            <a:ext cx="4814280" cy="225720"/>
           </a:xfrm>
           <a:prstGeom prst="rect">
             <a:avLst/>
@@ -19601,7 +19591,7 @@
         <p:spPr>
           <a:xfrm>
             <a:off x="6841800" y="4118040"/>
-            <a:ext cx="4806360" cy="193680"/>
+            <a:ext cx="4806000" cy="193320"/>
           </a:xfrm>
           <a:prstGeom prst="rect">
             <a:avLst/>
@@ -19663,7 +19653,7 @@
         <p:spPr>
           <a:xfrm>
             <a:off x="1476360" y="4572000"/>
-            <a:ext cx="4036320" cy="712800"/>
+            <a:ext cx="4035960" cy="712440"/>
           </a:xfrm>
           <a:custGeom>
             <a:avLst/>
@@ -19714,7 +19704,7 @@
         <p:spPr>
           <a:xfrm>
             <a:off x="1532880" y="4701600"/>
-            <a:ext cx="3849840" cy="226080"/>
+            <a:ext cx="3849480" cy="225720"/>
           </a:xfrm>
           <a:prstGeom prst="rect">
             <a:avLst/>
@@ -19766,7 +19756,7 @@
         <p:spPr>
           <a:xfrm>
             <a:off x="1541160" y="4961160"/>
-            <a:ext cx="3841560" cy="193680"/>
+            <a:ext cx="3841200" cy="193320"/>
           </a:xfrm>
           <a:prstGeom prst="rect">
             <a:avLst/>
@@ -19828,7 +19818,7 @@
         <p:spPr>
           <a:xfrm>
             <a:off x="6683760" y="5419080"/>
-            <a:ext cx="3987720" cy="720720"/>
+            <a:ext cx="3987360" cy="720360"/>
           </a:xfrm>
           <a:custGeom>
             <a:avLst/>
@@ -19882,7 +19872,7 @@
         <p:spPr>
           <a:xfrm>
             <a:off x="6817320" y="5553000"/>
-            <a:ext cx="3792960" cy="226080"/>
+            <a:ext cx="3792600" cy="225720"/>
           </a:xfrm>
           <a:prstGeom prst="rect">
             <a:avLst/>
@@ -19934,7 +19924,7 @@
         <p:spPr>
           <a:xfrm>
             <a:off x="6817320" y="5812200"/>
-            <a:ext cx="3785040" cy="193680"/>
+            <a:ext cx="3784680" cy="193320"/>
           </a:xfrm>
           <a:prstGeom prst="rect">
             <a:avLst/>
@@ -19986,7 +19976,7 @@
         <p:spPr>
           <a:xfrm>
             <a:off x="6031080" y="1467360"/>
-            <a:ext cx="128880" cy="128880"/>
+            <a:ext cx="128520" cy="128520"/>
           </a:xfrm>
           <a:custGeom>
             <a:avLst/>
@@ -20057,7 +20047,7 @@
         <p:spPr>
           <a:xfrm>
             <a:off x="6031080" y="2326680"/>
-            <a:ext cx="128880" cy="128880"/>
+            <a:ext cx="128520" cy="128520"/>
           </a:xfrm>
           <a:custGeom>
             <a:avLst/>
@@ -20128,7 +20118,7 @@
         <p:spPr>
           <a:xfrm>
             <a:off x="6031080" y="3177720"/>
-            <a:ext cx="128880" cy="128880"/>
+            <a:ext cx="128520" cy="128520"/>
           </a:xfrm>
           <a:custGeom>
             <a:avLst/>
@@ -20199,7 +20189,7 @@
         <p:spPr>
           <a:xfrm>
             <a:off x="6031080" y="4020840"/>
-            <a:ext cx="128880" cy="128880"/>
+            <a:ext cx="128520" cy="128520"/>
           </a:xfrm>
           <a:custGeom>
             <a:avLst/>
@@ -20270,7 +20260,7 @@
         <p:spPr>
           <a:xfrm>
             <a:off x="6031080" y="4863960"/>
-            <a:ext cx="128880" cy="128880"/>
+            <a:ext cx="128520" cy="128520"/>
           </a:xfrm>
           <a:custGeom>
             <a:avLst/>
@@ -20341,7 +20331,7 @@
         <p:spPr>
           <a:xfrm>
             <a:off x="6031080" y="5715000"/>
-            <a:ext cx="128880" cy="128880"/>
+            <a:ext cx="128520" cy="128520"/>
           </a:xfrm>
           <a:custGeom>
             <a:avLst/>
@@ -20449,7 +20439,7 @@
         <p:spPr>
           <a:xfrm>
             <a:off x="380880" y="380880"/>
-            <a:ext cx="11505600" cy="227880"/>
+            <a:ext cx="11505240" cy="227520"/>
           </a:xfrm>
           <a:prstGeom prst="rect">
             <a:avLst/>
@@ -20477,7 +20467,7 @@
               <a:buNone/>
             </a:pPr>
             <a:r>
-              <a:rPr b="1" lang="en-US" sz="1200" spc="55" strike="noStrike">
+              <a:rPr b="1" lang="en-US" sz="1200" spc="52" strike="noStrike">
                 <a:solidFill>
                   <a:srgbClr val="0984e3"/>
                 </a:solidFill>
@@ -20501,7 +20491,7 @@
         <p:spPr>
           <a:xfrm>
             <a:off x="380880" y="685800"/>
-            <a:ext cx="11657880" cy="456480"/>
+            <a:ext cx="11657520" cy="456120"/>
           </a:xfrm>
           <a:prstGeom prst="rect">
             <a:avLst/>
@@ -20553,7 +20543,7 @@
         <p:spPr>
           <a:xfrm>
             <a:off x="380880" y="1371600"/>
-            <a:ext cx="4390200" cy="3047400"/>
+            <a:ext cx="4389840" cy="3047040"/>
           </a:xfrm>
           <a:prstGeom prst="roundRect">
             <a:avLst>
@@ -20585,7 +20575,7 @@
         <p:spPr>
           <a:xfrm>
             <a:off x="399960" y="4648320"/>
-            <a:ext cx="4371120" cy="1142280"/>
+            <a:ext cx="4370760" cy="1141920"/>
           </a:xfrm>
           <a:custGeom>
             <a:avLst/>
@@ -20636,7 +20626,7 @@
         <p:spPr>
           <a:xfrm>
             <a:off x="399960" y="4648320"/>
-            <a:ext cx="37440" cy="1142280"/>
+            <a:ext cx="37080" cy="1141920"/>
           </a:xfrm>
           <a:custGeom>
             <a:avLst/>
@@ -20687,7 +20677,7 @@
         <p:spPr>
           <a:xfrm>
             <a:off x="609480" y="4838760"/>
-            <a:ext cx="4047480" cy="494640"/>
+            <a:ext cx="4047120" cy="494280"/>
           </a:xfrm>
           <a:prstGeom prst="rect">
             <a:avLst/>
@@ -20739,7 +20729,7 @@
         <p:spPr>
           <a:xfrm>
             <a:off x="609480" y="5410080"/>
-            <a:ext cx="4037760" cy="189720"/>
+            <a:ext cx="4037400" cy="189360"/>
           </a:xfrm>
           <a:prstGeom prst="rect">
             <a:avLst/>
@@ -20801,7 +20791,7 @@
         <p:spPr>
           <a:xfrm>
             <a:off x="5074920" y="1371600"/>
-            <a:ext cx="6847920" cy="304200"/>
+            <a:ext cx="6847560" cy="303840"/>
           </a:xfrm>
           <a:prstGeom prst="rect">
             <a:avLst/>
@@ -20853,7 +20843,7 @@
         <p:spPr>
           <a:xfrm>
             <a:off x="5074920" y="1752480"/>
-            <a:ext cx="6809760" cy="990000"/>
+            <a:ext cx="6809400" cy="989640"/>
           </a:xfrm>
           <a:prstGeom prst="rect">
             <a:avLst/>
@@ -20905,7 +20895,7 @@
         <p:spPr>
           <a:xfrm>
             <a:off x="5074920" y="2895480"/>
-            <a:ext cx="6847920" cy="304200"/>
+            <a:ext cx="6847560" cy="303840"/>
           </a:xfrm>
           <a:prstGeom prst="rect">
             <a:avLst/>
@@ -20957,7 +20947,7 @@
         <p:spPr>
           <a:xfrm>
             <a:off x="5074920" y="3276720"/>
-            <a:ext cx="6809760" cy="990000"/>
+            <a:ext cx="6809400" cy="989640"/>
           </a:xfrm>
           <a:prstGeom prst="rect">
             <a:avLst/>
@@ -21029,7 +21019,7 @@
         <p:spPr>
           <a:xfrm>
             <a:off x="5074920" y="4419720"/>
-            <a:ext cx="6847920" cy="304200"/>
+            <a:ext cx="6847560" cy="303840"/>
           </a:xfrm>
           <a:prstGeom prst="rect">
             <a:avLst/>
@@ -21081,7 +21071,7 @@
         <p:spPr>
           <a:xfrm>
             <a:off x="5074920" y="4800600"/>
-            <a:ext cx="6809760" cy="990000"/>
+            <a:ext cx="6809400" cy="989640"/>
           </a:xfrm>
           <a:prstGeom prst="rect">
             <a:avLst/>
@@ -21190,7 +21180,7 @@
         <p:spPr>
           <a:xfrm>
             <a:off x="609480" y="1781280"/>
-            <a:ext cx="12191400" cy="1218600"/>
+            <a:ext cx="12191040" cy="1218240"/>
           </a:xfrm>
           <a:prstGeom prst="rect">
             <a:avLst/>
@@ -21244,7 +21234,7 @@
         <p:spPr>
           <a:xfrm>
             <a:off x="609480" y="3152880"/>
-            <a:ext cx="11867400" cy="1142280"/>
+            <a:ext cx="11867040" cy="1141920"/>
           </a:xfrm>
           <a:prstGeom prst="rect">
             <a:avLst/>
@@ -21317,7 +21307,7 @@
         <p:spPr>
           <a:xfrm>
             <a:off x="609480" y="4524480"/>
-            <a:ext cx="1218600" cy="18360"/>
+            <a:ext cx="1218240" cy="18000"/>
           </a:xfrm>
           <a:custGeom>
             <a:avLst/>
@@ -21368,7 +21358,7 @@
         <p:spPr>
           <a:xfrm>
             <a:off x="609480" y="4772160"/>
-            <a:ext cx="11696040" cy="304200"/>
+            <a:ext cx="11695680" cy="303840"/>
           </a:xfrm>
           <a:prstGeom prst="rect">
             <a:avLst/>
@@ -21457,7 +21447,7 @@
         <p:spPr>
           <a:xfrm>
             <a:off x="380880" y="380880"/>
-            <a:ext cx="11505600" cy="227880"/>
+            <a:ext cx="11505240" cy="227520"/>
           </a:xfrm>
           <a:prstGeom prst="rect">
             <a:avLst/>
@@ -21485,7 +21475,7 @@
               <a:buNone/>
             </a:pPr>
             <a:r>
-              <a:rPr b="1" lang="en-US" sz="1200" spc="55" strike="noStrike">
+              <a:rPr b="1" lang="en-US" sz="1200" spc="52" strike="noStrike">
                 <a:solidFill>
                   <a:srgbClr val="0984e3"/>
                 </a:solidFill>
@@ -21509,7 +21499,7 @@
         <p:spPr>
           <a:xfrm>
             <a:off x="380880" y="685800"/>
-            <a:ext cx="11657880" cy="456480"/>
+            <a:ext cx="11657520" cy="456120"/>
           </a:xfrm>
           <a:prstGeom prst="rect">
             <a:avLst/>
@@ -21561,7 +21551,7 @@
         <p:spPr>
           <a:xfrm>
             <a:off x="380880" y="1371600"/>
-            <a:ext cx="5657040" cy="1237680"/>
+            <a:ext cx="5656680" cy="1237320"/>
           </a:xfrm>
           <a:prstGeom prst="rect">
             <a:avLst/>
@@ -21623,7 +21613,7 @@
         <p:spPr>
           <a:xfrm>
             <a:off x="380880" y="2762280"/>
-            <a:ext cx="5647680" cy="837360"/>
+            <a:ext cx="5647320" cy="837000"/>
           </a:xfrm>
           <a:prstGeom prst="rect">
             <a:avLst/>
@@ -21675,7 +21665,7 @@
         <p:spPr>
           <a:xfrm>
             <a:off x="399960" y="3750480"/>
-            <a:ext cx="5542920" cy="1599480"/>
+            <a:ext cx="5542560" cy="1599120"/>
           </a:xfrm>
           <a:custGeom>
             <a:avLst/>
@@ -21726,7 +21716,7 @@
         <p:spPr>
           <a:xfrm>
             <a:off x="399960" y="3750480"/>
-            <a:ext cx="37440" cy="1599480"/>
+            <a:ext cx="37080" cy="1599120"/>
           </a:xfrm>
           <a:custGeom>
             <a:avLst/>
@@ -21777,7 +21767,7 @@
         <p:spPr>
           <a:xfrm>
             <a:off x="609480" y="3940920"/>
-            <a:ext cx="5238000" cy="266040"/>
+            <a:ext cx="5237640" cy="265680"/>
           </a:xfrm>
           <a:prstGeom prst="rect">
             <a:avLst/>
@@ -21829,7 +21819,7 @@
         <p:spPr>
           <a:xfrm>
             <a:off x="609480" y="4321800"/>
-            <a:ext cx="5218920" cy="227880"/>
+            <a:ext cx="5218560" cy="227520"/>
           </a:xfrm>
           <a:prstGeom prst="rect">
             <a:avLst/>
@@ -21891,7 +21881,7 @@
         <p:spPr>
           <a:xfrm>
             <a:off x="609480" y="4626720"/>
-            <a:ext cx="5218920" cy="227880"/>
+            <a:ext cx="5218560" cy="227520"/>
           </a:xfrm>
           <a:prstGeom prst="rect">
             <a:avLst/>
@@ -21953,7 +21943,7 @@
         <p:spPr>
           <a:xfrm>
             <a:off x="609480" y="4931640"/>
-            <a:ext cx="5218920" cy="227880"/>
+            <a:ext cx="5218560" cy="227520"/>
           </a:xfrm>
           <a:prstGeom prst="rect">
             <a:avLst/>
@@ -22015,7 +22005,7 @@
         <p:spPr>
           <a:xfrm>
             <a:off x="6253200" y="1618200"/>
-            <a:ext cx="5552280" cy="3485520"/>
+            <a:ext cx="5551920" cy="3485160"/>
           </a:xfrm>
           <a:custGeom>
             <a:avLst/>
@@ -22069,7 +22059,7 @@
         <p:spPr>
           <a:xfrm>
             <a:off x="6438960" y="1851480"/>
-            <a:ext cx="5180760" cy="266040"/>
+            <a:ext cx="5180400" cy="265680"/>
           </a:xfrm>
           <a:prstGeom prst="rect">
             <a:avLst/>
@@ -22121,7 +22111,7 @@
         <p:spPr>
           <a:xfrm>
             <a:off x="6448320" y="2270520"/>
-            <a:ext cx="5161680" cy="227880"/>
+            <a:ext cx="5161320" cy="227520"/>
           </a:xfrm>
           <a:prstGeom prst="rect">
             <a:avLst/>
@@ -22496,7 +22486,7 @@
                           <a:latin typeface="微软雅黑"/>
                           <a:ea typeface="微软雅黑"/>
                         </a:rPr>
-                        <a:t>Firm A: Keep</a:t>
+                        <a:t>Firm A: Lower Prices</a:t>
                       </a:r>
                       <a:endParaRPr b="0" lang="en-HK" sz="1200" spc="-1" strike="noStrike">
                         <a:latin typeface="Arial"/>
@@ -22549,7 +22539,7 @@
                           <a:latin typeface="微软雅黑"/>
                           <a:ea typeface="微软雅黑"/>
                         </a:rPr>
-                        <a:t>(2, 10)</a:t>
+                        <a:t>(4, 4)</a:t>
                       </a:r>
                       <a:endParaRPr b="0" lang="en-HK" sz="1200" spc="-1" strike="noStrike">
                         <a:latin typeface="Arial"/>
@@ -22645,7 +22635,7 @@
         <p:spPr>
           <a:xfrm>
             <a:off x="6486480" y="4218480"/>
-            <a:ext cx="5085720" cy="8640"/>
+            <a:ext cx="5085360" cy="8280"/>
           </a:xfrm>
           <a:custGeom>
             <a:avLst/>
@@ -22696,7 +22686,7 @@
         <p:spPr>
           <a:xfrm>
             <a:off x="6486480" y="4375440"/>
-            <a:ext cx="5161680" cy="494640"/>
+            <a:ext cx="5161320" cy="494280"/>
           </a:xfrm>
           <a:prstGeom prst="rect">
             <a:avLst/>

</xml_diff>